<commit_message>
@ Add ECOGRID concept docs, API references, brain, and HTML presentation
Co-Authored-By: Claude Opus 4.8 (1M context) <noreply@anthropic.com>
@
</commit_message>
<xml_diff>
--- a/SmartGrid/Commercial/ECOGRID_RESORT_Investisseurs_FR.pptx
+++ b/SmartGrid/Commercial/ECOGRID_RESORT_Investisseurs_FR.pptx
@@ -4,11 +4,9 @@
   <p:sldMasterIdLst>
     <p:sldMasterId id="2147483648" r:id="rId1"/>
   </p:sldMasterIdLst>
-  <p:notesMasterIdLst>
-    <p:notesMasterId r:id="rId12"/>
-  </p:notesMasterIdLst>
   <p:sldIdLst>
     <p:sldId id="256" r:id="rId2"/>
+    <p:sldId id="266" r:id="rId17"/>
     <p:sldId id="257" r:id="rId3"/>
     <p:sldId id="258" r:id="rId4"/>
     <p:sldId id="259" r:id="rId5"/>
@@ -19,6 +17,9 @@
     <p:sldId id="264" r:id="rId10"/>
     <p:sldId id="265" r:id="rId11"/>
   </p:sldIdLst>
+  <p:notesMasterIdLst>
+    <p:notesMasterId r:id="rId12"/>
+  </p:notesMasterIdLst>
   <p:sldSz cx="12192000" cy="6858000"/>
   <p:notesSz cx="6858000" cy="12192000"/>
   <p:defaultTextStyle>
@@ -113,20 +114,13 @@
       </a:defRPr>
     </a:lvl9pPr>
   </p:defaultTextStyle>
-  <p:extLst>
-    <p:ext uri="{EFAFB233-063F-42B5-8137-9DF3F51BA10A}">
-      <p15:sldGuideLst xmlns:p15="http://schemas.microsoft.com/office/powerpoint/2012/main"/>
-    </p:ext>
-  </p:extLst>
 </p:presentation>
 </file>
 
-<file path=ppt/charts/chart1.xml><?xml version="1.0" encoding="utf-8"?>
-<c:chartSpace xmlns:c="http://schemas.openxmlformats.org/drawingml/2006/chart" xmlns:a="http://schemas.openxmlformats.org/drawingml/2006/main" xmlns:r="http://schemas.openxmlformats.org/officeDocument/2006/relationships" xmlns:c16r2="http://schemas.microsoft.com/office/drawing/2015/06/chart">
+<file path=ppt/charts/chart2.xml><?xml version="1.0" encoding="utf-8"?>
+<c:chartSpace xmlns:c="http://schemas.openxmlformats.org/drawingml/2006/chart" xmlns:a="http://schemas.openxmlformats.org/drawingml/2006/main" xmlns:r="http://schemas.openxmlformats.org/officeDocument/2006/relationships">
   <c:date1904 val="0"/>
-  <c:lang val="en-GB"/>
   <c:roundedCorners val="1"/>
-  <c:style val="2"/>
   <c:chart>
     <c:autoTitleDeleted val="1"/>
     <c:plotArea>
@@ -169,11 +163,6 @@
               </a:solidFill>
               <a:effectLst/>
             </c:spPr>
-            <c:extLst>
-              <c:ext xmlns:c16="http://schemas.microsoft.com/office/drawing/2014/chart" uri="{C3380CC4-5D6E-409C-BE32-E72D297353CC}">
-                <c16:uniqueId val="{00000001-0EB7-4E18-B191-31AD666C3520}"/>
-              </c:ext>
-            </c:extLst>
           </c:dPt>
           <c:dPt>
             <c:idx val="1"/>
@@ -184,11 +173,6 @@
               </a:solidFill>
               <a:effectLst/>
             </c:spPr>
-            <c:extLst>
-              <c:ext xmlns:c16="http://schemas.microsoft.com/office/drawing/2014/chart" uri="{C3380CC4-5D6E-409C-BE32-E72D297353CC}">
-                <c16:uniqueId val="{00000003-0EB7-4E18-B191-31AD666C3520}"/>
-              </c:ext>
-            </c:extLst>
           </c:dPt>
           <c:dPt>
             <c:idx val="2"/>
@@ -199,11 +183,6 @@
               </a:solidFill>
               <a:effectLst/>
             </c:spPr>
-            <c:extLst>
-              <c:ext xmlns:c16="http://schemas.microsoft.com/office/drawing/2014/chart" uri="{C3380CC4-5D6E-409C-BE32-E72D297353CC}">
-                <c16:uniqueId val="{00000005-0EB7-4E18-B191-31AD666C3520}"/>
-              </c:ext>
-            </c:extLst>
           </c:dPt>
           <c:dPt>
             <c:idx val="3"/>
@@ -214,11 +193,6 @@
               </a:solidFill>
               <a:effectLst/>
             </c:spPr>
-            <c:extLst>
-              <c:ext xmlns:c16="http://schemas.microsoft.com/office/drawing/2014/chart" uri="{C3380CC4-5D6E-409C-BE32-E72D297353CC}">
-                <c16:uniqueId val="{00000007-0EB7-4E18-B191-31AD666C3520}"/>
-              </c:ext>
-            </c:extLst>
           </c:dPt>
           <c:dLbls>
             <c:dLbl>
@@ -237,7 +211,6 @@
                       <a:latin typeface="Arial"/>
                     </a:defRPr>
                   </a:pPr>
-                  <a:endParaRPr lang="en-US"/>
                 </a:p>
               </c:txPr>
               <c:showLegendKey val="0"/>
@@ -246,12 +219,6 @@
               <c:showSerName val="0"/>
               <c:showPercent val="1"/>
               <c:showBubbleSize val="0"/>
-              <c:extLst>
-                <c:ext xmlns:c15="http://schemas.microsoft.com/office/drawing/2012/chart" uri="{CE6537A1-D6FC-4f65-9D91-7224C49458BB}"/>
-                <c:ext xmlns:c16="http://schemas.microsoft.com/office/drawing/2014/chart" uri="{C3380CC4-5D6E-409C-BE32-E72D297353CC}">
-                  <c16:uniqueId val="{00000001-0EB7-4E18-B191-31AD666C3520}"/>
-                </c:ext>
-              </c:extLst>
             </c:dLbl>
             <c:dLbl>
               <c:idx val="1"/>
@@ -269,7 +236,6 @@
                       <a:latin typeface="Arial"/>
                     </a:defRPr>
                   </a:pPr>
-                  <a:endParaRPr lang="en-US"/>
                 </a:p>
               </c:txPr>
               <c:showLegendKey val="0"/>
@@ -278,12 +244,6 @@
               <c:showSerName val="0"/>
               <c:showPercent val="1"/>
               <c:showBubbleSize val="0"/>
-              <c:extLst>
-                <c:ext xmlns:c15="http://schemas.microsoft.com/office/drawing/2012/chart" uri="{CE6537A1-D6FC-4f65-9D91-7224C49458BB}"/>
-                <c:ext xmlns:c16="http://schemas.microsoft.com/office/drawing/2014/chart" uri="{C3380CC4-5D6E-409C-BE32-E72D297353CC}">
-                  <c16:uniqueId val="{00000003-0EB7-4E18-B191-31AD666C3520}"/>
-                </c:ext>
-              </c:extLst>
             </c:dLbl>
             <c:dLbl>
               <c:idx val="2"/>
@@ -301,7 +261,6 @@
                       <a:latin typeface="Arial"/>
                     </a:defRPr>
                   </a:pPr>
-                  <a:endParaRPr lang="en-US"/>
                 </a:p>
               </c:txPr>
               <c:showLegendKey val="0"/>
@@ -310,12 +269,6 @@
               <c:showSerName val="0"/>
               <c:showPercent val="1"/>
               <c:showBubbleSize val="0"/>
-              <c:extLst>
-                <c:ext xmlns:c15="http://schemas.microsoft.com/office/drawing/2012/chart" uri="{CE6537A1-D6FC-4f65-9D91-7224C49458BB}"/>
-                <c:ext xmlns:c16="http://schemas.microsoft.com/office/drawing/2014/chart" uri="{C3380CC4-5D6E-409C-BE32-E72D297353CC}">
-                  <c16:uniqueId val="{00000005-0EB7-4E18-B191-31AD666C3520}"/>
-                </c:ext>
-              </c:extLst>
             </c:dLbl>
             <c:dLbl>
               <c:idx val="3"/>
@@ -333,7 +286,6 @@
                       <a:latin typeface="Arial"/>
                     </a:defRPr>
                   </a:pPr>
-                  <a:endParaRPr lang="en-US"/>
                 </a:p>
               </c:txPr>
               <c:showLegendKey val="0"/>
@@ -342,21 +294,8 @@
               <c:showSerName val="0"/>
               <c:showPercent val="1"/>
               <c:showBubbleSize val="0"/>
-              <c:extLst>
-                <c:ext xmlns:c15="http://schemas.microsoft.com/office/drawing/2012/chart" uri="{CE6537A1-D6FC-4f65-9D91-7224C49458BB}"/>
-                <c:ext xmlns:c16="http://schemas.microsoft.com/office/drawing/2014/chart" uri="{C3380CC4-5D6E-409C-BE32-E72D297353CC}">
-                  <c16:uniqueId val="{00000007-0EB7-4E18-B191-31AD666C3520}"/>
-                </c:ext>
-              </c:extLst>
             </c:dLbl>
             <c:numFmt formatCode="0%" sourceLinked="0"/>
-            <c:spPr>
-              <a:noFill/>
-              <a:ln>
-                <a:noFill/>
-              </a:ln>
-              <a:effectLst/>
-            </c:spPr>
             <c:txPr>
               <a:bodyPr/>
               <a:lstStyle/>
@@ -369,7 +308,6 @@
                     <a:latin typeface="Arial"/>
                   </a:defRPr>
                 </a:pPr>
-                <a:endParaRPr lang="en-US"/>
               </a:p>
             </c:txPr>
             <c:showLegendKey val="0"/>
@@ -379,9 +317,6 @@
             <c:showPercent val="1"/>
             <c:showBubbleSize val="0"/>
             <c:showLeaderLines val="0"/>
-            <c:extLst>
-              <c:ext xmlns:c15="http://schemas.microsoft.com/office/drawing/2012/chart" uri="{CE6537A1-D6FC-4f65-9D91-7224C49458BB}"/>
-            </c:extLst>
           </c:dLbls>
           <c:cat>
             <c:strRef>
@@ -407,7 +342,6 @@
             <c:numRef>
               <c:f>Sheet1!$B$2:$B$5</c:f>
               <c:numCache>
-                <c:formatCode>General</c:formatCode>
                 <c:ptCount val="4"/>
                 <c:pt idx="0">
                   <c:v>68</c:v>
@@ -424,21 +358,7 @@
               </c:numCache>
             </c:numRef>
           </c:val>
-          <c:extLst>
-            <c:ext xmlns:c16="http://schemas.microsoft.com/office/drawing/2014/chart" uri="{C3380CC4-5D6E-409C-BE32-E72D297353CC}">
-              <c16:uniqueId val="{00000008-0EB7-4E18-B191-31AD666C3520}"/>
-            </c:ext>
-          </c:extLst>
         </c:ser>
-        <c:dLbls>
-          <c:showLegendKey val="0"/>
-          <c:showVal val="0"/>
-          <c:showCatName val="0"/>
-          <c:showSerName val="0"/>
-          <c:showPercent val="0"/>
-          <c:showBubbleSize val="0"/>
-          <c:showLeaderLines val="0"/>
-        </c:dLbls>
         <c:firstSliceAng val="0"/>
         <c:holeSize val="58"/>
       </c:doughnutChart>
@@ -470,7 +390,6 @@
     </c:legend>
     <c:plotVisOnly val="1"/>
     <c:dispBlanksAs val="span"/>
-    <c:showDLblsOverMax val="1"/>
   </c:chart>
   <c:spPr>
     <a:noFill/>
@@ -507,10 +426,234 @@
           <a:chExt cx="0" cy="0"/>
         </a:xfrm>
       </p:grpSpPr>
+      <p:sp>
+        <p:nvSpPr>
+          <p:cNvPr id="2" name="Header Placeholder 1"/>
+          <p:cNvSpPr>
+            <a:spLocks noGrp="1"/>
+          </p:cNvSpPr>
+          <p:nvPr>
+            <p:ph type="hdr" sz="quarter"/>
+          </p:nvPr>
+        </p:nvSpPr>
+        <p:spPr>
+          <a:xfrm>
+            <a:off x="0" y="0"/>
+            <a:ext cx="2971800" cy="458788"/>
+          </a:xfrm>
+          <a:prstGeom prst="rect">
+            <a:avLst/>
+          </a:prstGeom>
+        </p:spPr>
+        <p:txBody>
+          <a:bodyPr vert="horz" lIns="91440" tIns="45720" rIns="91440" bIns="45720" rtlCol="0"/>
+          <a:lstStyle>
+            <a:lvl1pPr algn="l">
+              <a:defRPr sz="1200"/>
+            </a:lvl1pPr>
+          </a:lstStyle>
+          <a:p>
+            <a:endParaRPr lang="en-US"/>
+          </a:p>
+        </p:txBody>
+      </p:sp>
+      <p:sp>
+        <p:nvSpPr>
+          <p:cNvPr id="3" name="Date Placeholder 2"/>
+          <p:cNvSpPr>
+            <a:spLocks noGrp="1"/>
+          </p:cNvSpPr>
+          <p:nvPr>
+            <p:ph type="dt" idx="1"/>
+          </p:nvPr>
+        </p:nvSpPr>
+        <p:spPr>
+          <a:xfrm>
+            <a:off x="3884613" y="0"/>
+            <a:ext cx="2971800" cy="458788"/>
+          </a:xfrm>
+          <a:prstGeom prst="rect">
+            <a:avLst/>
+          </a:prstGeom>
+        </p:spPr>
+        <p:txBody>
+          <a:bodyPr vert="horz" lIns="91440" tIns="45720" rIns="91440" bIns="45720" rtlCol="0"/>
+          <a:lstStyle>
+            <a:lvl1pPr algn="r">
+              <a:defRPr sz="1200"/>
+            </a:lvl1pPr>
+          </a:lstStyle>
+          <a:p>
+            <a:fld id="{5282F153-3F37-0F45-9E97-73ACFA13230C}" type="datetimeFigureOut">
+              <a:rPr lang="en-US"/>
+              <a:t>7/23/19</a:t>
+            </a:fld>
+            <a:endParaRPr lang="en-US"/>
+          </a:p>
+        </p:txBody>
+      </p:sp>
+      <p:sp>
+        <p:nvSpPr>
+          <p:cNvPr id="4" name="Slide Image Placeholder 3"/>
+          <p:cNvSpPr>
+            <a:spLocks noGrp="1" noRot="1" noChangeAspect="1"/>
+          </p:cNvSpPr>
+          <p:nvPr>
+            <p:ph type="sldImg" idx="2"/>
+          </p:nvPr>
+        </p:nvSpPr>
+        <p:spPr>
+          <a:xfrm>
+            <a:off x="685800" y="1143000"/>
+            <a:ext cx="5486400" cy="3086100"/>
+          </a:xfrm>
+          <a:prstGeom prst="rect">
+            <a:avLst/>
+          </a:prstGeom>
+          <a:noFill/>
+          <a:ln w="12700">
+            <a:solidFill>
+              <a:prstClr val="black"/>
+            </a:solidFill>
+          </a:ln>
+        </p:spPr>
+        <p:txBody>
+          <a:bodyPr vert="horz" lIns="91440" tIns="45720" rIns="91440" bIns="45720" rtlCol="0" anchor="ctr"/>
+          <a:lstStyle/>
+          <a:p>
+            <a:endParaRPr lang="en-US"/>
+          </a:p>
+        </p:txBody>
+      </p:sp>
+      <p:sp>
+        <p:nvSpPr>
+          <p:cNvPr id="5" name="Notes Placeholder 4"/>
+          <p:cNvSpPr>
+            <a:spLocks noGrp="1"/>
+          </p:cNvSpPr>
+          <p:nvPr>
+            <p:ph type="body" sz="quarter" idx="3"/>
+          </p:nvPr>
+        </p:nvSpPr>
+        <p:spPr>
+          <a:xfrm>
+            <a:off x="685800" y="4400550"/>
+            <a:ext cx="5486400" cy="3600450"/>
+          </a:xfrm>
+          <a:prstGeom prst="rect">
+            <a:avLst/>
+          </a:prstGeom>
+        </p:spPr>
+        <p:txBody>
+          <a:bodyPr vert="horz" lIns="91440" tIns="45720" rIns="91440" bIns="45720" rtlCol="0"/>
+          <a:lstStyle/>
+          <a:p>
+            <a:pPr lvl="0"/>
+            <a:r>
+              <a:rPr lang="en-US"/>
+              <a:t>Click to edit Master text styles</a:t>
+            </a:r>
+          </a:p>
+          <a:p>
+            <a:pPr lvl="1"/>
+            <a:r>
+              <a:rPr lang="en-US"/>
+              <a:t>Second level</a:t>
+            </a:r>
+          </a:p>
+          <a:p>
+            <a:pPr lvl="2"/>
+            <a:r>
+              <a:rPr lang="en-US"/>
+              <a:t>Third level</a:t>
+            </a:r>
+          </a:p>
+          <a:p>
+            <a:pPr lvl="3"/>
+            <a:r>
+              <a:rPr lang="en-US"/>
+              <a:t>Fourth level</a:t>
+            </a:r>
+          </a:p>
+          <a:p>
+            <a:pPr lvl="4"/>
+            <a:r>
+              <a:rPr lang="en-US"/>
+              <a:t>Fifth level</a:t>
+            </a:r>
+          </a:p>
+        </p:txBody>
+      </p:sp>
+      <p:sp>
+        <p:nvSpPr>
+          <p:cNvPr id="6" name="Footer Placeholder 5"/>
+          <p:cNvSpPr>
+            <a:spLocks noGrp="1"/>
+          </p:cNvSpPr>
+          <p:nvPr>
+            <p:ph type="ftr" sz="quarter" idx="4"/>
+          </p:nvPr>
+        </p:nvSpPr>
+        <p:spPr>
+          <a:xfrm>
+            <a:off x="0" y="8685213"/>
+            <a:ext cx="2971800" cy="458787"/>
+          </a:xfrm>
+          <a:prstGeom prst="rect">
+            <a:avLst/>
+          </a:prstGeom>
+        </p:spPr>
+        <p:txBody>
+          <a:bodyPr vert="horz" lIns="91440" tIns="45720" rIns="91440" bIns="45720" rtlCol="0" anchor="b"/>
+          <a:lstStyle>
+            <a:lvl1pPr algn="l">
+              <a:defRPr sz="1200"/>
+            </a:lvl1pPr>
+          </a:lstStyle>
+          <a:p>
+            <a:endParaRPr lang="en-US"/>
+          </a:p>
+        </p:txBody>
+      </p:sp>
+      <p:sp>
+        <p:nvSpPr>
+          <p:cNvPr id="7" name="Slide Number Placeholder 6"/>
+          <p:cNvSpPr>
+            <a:spLocks noGrp="1"/>
+          </p:cNvSpPr>
+          <p:nvPr>
+            <p:ph type="sldNum" sz="quarter" idx="5"/>
+          </p:nvPr>
+        </p:nvSpPr>
+        <p:spPr>
+          <a:xfrm>
+            <a:off x="3884613" y="8685213"/>
+            <a:ext cx="2971800" cy="458787"/>
+          </a:xfrm>
+          <a:prstGeom prst="rect">
+            <a:avLst/>
+          </a:prstGeom>
+        </p:spPr>
+        <p:txBody>
+          <a:bodyPr vert="horz" lIns="91440" tIns="45720" rIns="91440" bIns="45720" rtlCol="0" anchor="b"/>
+          <a:lstStyle>
+            <a:lvl1pPr algn="r">
+              <a:defRPr sz="1200"/>
+            </a:lvl1pPr>
+          </a:lstStyle>
+          <a:p>
+            <a:fld id="{CE5E9CC1-C706-0F49-92D6-E571CC5EEA8F}" type="slidenum">
+              <a:rPr lang="en-US"/>
+              <a:t>‹#›</a:t>
+            </a:fld>
+            <a:endParaRPr lang="en-US"/>
+          </a:p>
+        </p:txBody>
+      </p:sp>
     </p:spTree>
     <p:extLst>
       <p:ext uri="{BB962C8B-B14F-4D97-AF65-F5344CB8AC3E}">
-        <p14:creationId xmlns:p14="http://schemas.microsoft.com/office/powerpoint/2010/main" val="2108513668"/>
+        <p14:creationId xmlns:p14="http://schemas.microsoft.com/office/powerpoint/2010/main" val="1024086991"/>
       </p:ext>
     </p:extLst>
   </p:cSld>
@@ -654,6 +797,10 @@
           <a:bodyPr/>
           <a:lstStyle/>
           <a:p>
+            <a:r>
+              <a:rPr lang="en-US" dirty="0"/>
+              <a:t/>
+            </a:r>
             <a:endParaRPr lang="en-US" dirty="0"/>
           </a:p>
         </p:txBody>
@@ -738,6 +885,10 @@
           <a:bodyPr/>
           <a:lstStyle/>
           <a:p>
+            <a:r>
+              <a:rPr lang="en-US" dirty="0"/>
+              <a:t/>
+            </a:r>
             <a:endParaRPr lang="en-US" dirty="0"/>
           </a:p>
         </p:txBody>
@@ -822,6 +973,10 @@
           <a:bodyPr/>
           <a:lstStyle/>
           <a:p>
+            <a:r>
+              <a:rPr lang="en-US" dirty="0"/>
+              <a:t/>
+            </a:r>
             <a:endParaRPr lang="en-US" dirty="0"/>
           </a:p>
         </p:txBody>
@@ -906,6 +1061,10 @@
           <a:bodyPr/>
           <a:lstStyle/>
           <a:p>
+            <a:r>
+              <a:rPr lang="en-US" dirty="0"/>
+              <a:t/>
+            </a:r>
             <a:endParaRPr lang="en-US" dirty="0"/>
           </a:p>
         </p:txBody>
@@ -990,6 +1149,10 @@
           <a:bodyPr/>
           <a:lstStyle/>
           <a:p>
+            <a:r>
+              <a:rPr lang="en-US" dirty="0"/>
+              <a:t/>
+            </a:r>
             <a:endParaRPr lang="en-US" dirty="0"/>
           </a:p>
         </p:txBody>
@@ -1074,6 +1237,10 @@
           <a:bodyPr/>
           <a:lstStyle/>
           <a:p>
+            <a:r>
+              <a:rPr lang="en-US" dirty="0"/>
+              <a:t/>
+            </a:r>
             <a:endParaRPr lang="en-US" dirty="0"/>
           </a:p>
         </p:txBody>
@@ -1158,6 +1325,10 @@
           <a:bodyPr/>
           <a:lstStyle/>
           <a:p>
+            <a:r>
+              <a:rPr lang="en-US" dirty="0"/>
+              <a:t/>
+            </a:r>
             <a:endParaRPr lang="en-US" dirty="0"/>
           </a:p>
         </p:txBody>
@@ -1242,6 +1413,10 @@
           <a:bodyPr/>
           <a:lstStyle/>
           <a:p>
+            <a:r>
+              <a:rPr lang="en-US" dirty="0"/>
+              <a:t/>
+            </a:r>
             <a:endParaRPr lang="en-US" dirty="0"/>
           </a:p>
         </p:txBody>
@@ -1326,6 +1501,10 @@
           <a:bodyPr/>
           <a:lstStyle/>
           <a:p>
+            <a:r>
+              <a:rPr lang="en-US" dirty="0"/>
+              <a:t/>
+            </a:r>
             <a:endParaRPr lang="en-US" dirty="0"/>
           </a:p>
         </p:txBody>
@@ -1410,6 +1589,10 @@
           <a:bodyPr/>
           <a:lstStyle/>
           <a:p>
+            <a:r>
+              <a:rPr lang="en-US" dirty="0"/>
+              <a:t/>
+            </a:r>
             <a:endParaRPr lang="en-US" dirty="0"/>
           </a:p>
         </p:txBody>
@@ -1483,11 +1666,6 @@
 <file path=ppt/slideMasters/slideMaster1.xml><?xml version="1.0" encoding="utf-8"?>
 <p:sldMaster xmlns:a="http://schemas.openxmlformats.org/drawingml/2006/main" xmlns:r="http://schemas.openxmlformats.org/officeDocument/2006/relationships" xmlns:p="http://schemas.openxmlformats.org/presentationml/2006/main">
   <p:cSld>
-    <p:bg>
-      <p:bgRef idx="1001">
-        <a:schemeClr val="bg1"/>
-      </p:bgRef>
-    </p:bg>
     <p:spTree>
       <p:nvGrpSpPr>
         <p:cNvPr id="1" name=""/>
@@ -1770,7 +1948,6 @@
         <a:solidFill>
           <a:srgbClr val="0E2A3B"/>
         </a:solidFill>
-        <a:effectLst/>
       </p:bgPr>
     </p:bg>
     <p:spTree>
@@ -1808,10 +1985,7 @@
         </p:spPr>
         <p:txBody>
           <a:bodyPr/>
-          <a:lstStyle/>
-          <a:p>
-            <a:endParaRPr/>
-          </a:p>
+          <a:p/>
         </p:txBody>
       </p:sp>
       <p:sp>
@@ -1837,10 +2011,7 @@
         </p:spPr>
         <p:txBody>
           <a:bodyPr/>
-          <a:lstStyle/>
-          <a:p>
-            <a:endParaRPr/>
-          </a:p>
+          <a:p/>
         </p:txBody>
       </p:sp>
       <p:sp>
@@ -1864,11 +2035,11 @@
           <a:bodyPr wrap="square" lIns="0" tIns="0" rIns="0" bIns="0" rtlCol="0" anchor="ctr"/>
           <a:lstStyle/>
           <a:p>
-            <a:pPr marL="0" indent="0">
+            <a:pPr indent="0" marL="0">
               <a:buNone/>
             </a:pPr>
             <a:r>
-              <a:rPr lang="en-US" sz="1250" b="1" kern="0" spc="200" dirty="0">
+              <a:rPr lang="en-US" sz="1250" b="1" spc="200" kern="0" dirty="0">
                 <a:solidFill>
                   <a:srgbClr val="63E0D2"/>
                 </a:solidFill>
@@ -1903,7 +2074,7 @@
           <a:bodyPr wrap="square" lIns="0" tIns="0" rIns="0" bIns="0" rtlCol="0" anchor="ctr"/>
           <a:lstStyle/>
           <a:p>
-            <a:pPr marL="0" indent="0">
+            <a:pPr indent="0" marL="0">
               <a:buNone/>
             </a:pPr>
             <a:r>
@@ -1942,7 +2113,7 @@
           <a:bodyPr wrap="square" lIns="0" tIns="0" rIns="0" bIns="0" rtlCol="0" anchor="ctr"/>
           <a:lstStyle/>
           <a:p>
-            <a:pPr marL="0" indent="0">
+            <a:pPr indent="0" marL="0">
               <a:buNone/>
             </a:pPr>
             <a:r>
@@ -1981,10 +2152,7 @@
         </p:spPr>
         <p:txBody>
           <a:bodyPr/>
-          <a:lstStyle/>
-          <a:p>
-            <a:endParaRPr/>
-          </a:p>
+          <a:p/>
         </p:txBody>
       </p:sp>
       <p:sp>
@@ -2008,7 +2176,7 @@
           <a:bodyPr wrap="square" lIns="0" tIns="0" rIns="0" bIns="0" rtlCol="0" anchor="ctr"/>
           <a:lstStyle/>
           <a:p>
-            <a:pPr marL="0" indent="0">
+            <a:pPr indent="0" marL="0">
               <a:lnSpc>
                 <a:spcPct val="110000"/>
               </a:lnSpc>
@@ -2023,7 +2191,7 @@
                 <a:ea typeface="Calibri" pitchFamily="34" charset="-122"/>
                 <a:cs typeface="Calibri" pitchFamily="34" charset="-120"/>
               </a:rPr>
-              <a:t>Production solaire · stockage batterie · pilotage IA · application client — conçu pour le tourisme de plein air</a:t>
+              <a:t>Plateforme SaaS multi-marques qui orchestre production solaire, stockage et usages — conçue pour le tourisme de plein air</a:t>
             </a:r>
             <a:endParaRPr lang="en-US" sz="1300" dirty="0"/>
           </a:p>
@@ -2050,7 +2218,7 @@
           <a:bodyPr wrap="square" lIns="0" tIns="0" rIns="0" bIns="0" rtlCol="0" anchor="ctr"/>
           <a:lstStyle/>
           <a:p>
-            <a:pPr marL="0" indent="0">
+            <a:pPr indent="0" marL="0">
               <a:buNone/>
             </a:pPr>
             <a:r>
@@ -2084,7 +2252,6 @@
         <a:solidFill>
           <a:srgbClr val="0E2A3B"/>
         </a:solidFill>
-        <a:effectLst/>
       </p:bgPr>
     </p:bg>
     <p:spTree>
@@ -2124,10 +2291,7 @@
         </p:spPr>
         <p:txBody>
           <a:bodyPr/>
-          <a:lstStyle/>
-          <a:p>
-            <a:endParaRPr/>
-          </a:p>
+          <a:p/>
         </p:txBody>
       </p:sp>
       <p:sp>
@@ -2151,11 +2315,11 @@
           <a:bodyPr wrap="square" lIns="0" tIns="0" rIns="0" bIns="0" rtlCol="0" anchor="ctr"/>
           <a:lstStyle/>
           <a:p>
-            <a:pPr marL="0" indent="0">
+            <a:pPr indent="0" marL="0">
               <a:buNone/>
             </a:pPr>
             <a:r>
-              <a:rPr lang="en-US" sz="1200" b="1" kern="0" spc="200" dirty="0">
+              <a:rPr lang="en-US" sz="1200" b="1" spc="200" kern="0" dirty="0">
                 <a:solidFill>
                   <a:srgbClr val="63E0D2"/>
                 </a:solidFill>
@@ -2190,7 +2354,7 @@
           <a:bodyPr wrap="square" lIns="0" tIns="0" rIns="0" bIns="0" rtlCol="0" anchor="ctr"/>
           <a:lstStyle/>
           <a:p>
-            <a:pPr marL="0" indent="0">
+            <a:pPr indent="0" marL="0">
               <a:buNone/>
             </a:pPr>
             <a:r>
@@ -2234,10 +2398,7 @@
         </p:spPr>
         <p:txBody>
           <a:bodyPr/>
-          <a:lstStyle/>
-          <a:p>
-            <a:endParaRPr/>
-          </a:p>
+          <a:p/>
         </p:txBody>
       </p:sp>
       <p:sp>
@@ -2261,10 +2422,7 @@
         </p:spPr>
         <p:txBody>
           <a:bodyPr/>
-          <a:lstStyle/>
-          <a:p>
-            <a:endParaRPr/>
-          </a:p>
+          <a:p/>
         </p:txBody>
       </p:sp>
       <p:sp>
@@ -2288,7 +2446,7 @@
           <a:bodyPr wrap="square" lIns="0" tIns="0" rIns="0" bIns="0" rtlCol="0" anchor="ctr"/>
           <a:lstStyle/>
           <a:p>
-            <a:pPr marL="0" indent="0">
+            <a:pPr indent="0" marL="0">
               <a:buNone/>
             </a:pPr>
             <a:r>
@@ -2327,7 +2485,7 @@
           <a:bodyPr wrap="square" lIns="0" tIns="0" rIns="0" bIns="0" rtlCol="0" anchor="t"/>
           <a:lstStyle/>
           <a:p>
-            <a:pPr marL="0" indent="0">
+            <a:pPr indent="0" marL="0">
               <a:lnSpc>
                 <a:spcPct val="102000"/>
               </a:lnSpc>
@@ -2374,10 +2532,7 @@
         </p:spPr>
         <p:txBody>
           <a:bodyPr/>
-          <a:lstStyle/>
-          <a:p>
-            <a:endParaRPr/>
-          </a:p>
+          <a:p/>
         </p:txBody>
       </p:sp>
       <p:sp>
@@ -2401,10 +2556,7 @@
         </p:spPr>
         <p:txBody>
           <a:bodyPr/>
-          <a:lstStyle/>
-          <a:p>
-            <a:endParaRPr/>
-          </a:p>
+          <a:p/>
         </p:txBody>
       </p:sp>
       <p:sp>
@@ -2428,7 +2580,7 @@
           <a:bodyPr wrap="square" lIns="0" tIns="0" rIns="0" bIns="0" rtlCol="0" anchor="ctr"/>
           <a:lstStyle/>
           <a:p>
-            <a:pPr marL="0" indent="0">
+            <a:pPr indent="0" marL="0">
               <a:buNone/>
             </a:pPr>
             <a:r>
@@ -2467,7 +2619,7 @@
           <a:bodyPr wrap="square" lIns="0" tIns="0" rIns="0" bIns="0" rtlCol="0" anchor="t"/>
           <a:lstStyle/>
           <a:p>
-            <a:pPr marL="0" indent="0">
+            <a:pPr indent="0" marL="0">
               <a:lnSpc>
                 <a:spcPct val="102000"/>
               </a:lnSpc>
@@ -2514,10 +2666,7 @@
         </p:spPr>
         <p:txBody>
           <a:bodyPr/>
-          <a:lstStyle/>
-          <a:p>
-            <a:endParaRPr/>
-          </a:p>
+          <a:p/>
         </p:txBody>
       </p:sp>
       <p:sp>
@@ -2541,10 +2690,7 @@
         </p:spPr>
         <p:txBody>
           <a:bodyPr/>
-          <a:lstStyle/>
-          <a:p>
-            <a:endParaRPr/>
-          </a:p>
+          <a:p/>
         </p:txBody>
       </p:sp>
       <p:sp>
@@ -2568,7 +2714,7 @@
           <a:bodyPr wrap="square" lIns="0" tIns="0" rIns="0" bIns="0" rtlCol="0" anchor="ctr"/>
           <a:lstStyle/>
           <a:p>
-            <a:pPr marL="0" indent="0">
+            <a:pPr indent="0" marL="0">
               <a:buNone/>
             </a:pPr>
             <a:r>
@@ -2607,7 +2753,7 @@
           <a:bodyPr wrap="square" lIns="0" tIns="0" rIns="0" bIns="0" rtlCol="0" anchor="t"/>
           <a:lstStyle/>
           <a:p>
-            <a:pPr marL="0" indent="0">
+            <a:pPr indent="0" marL="0">
               <a:lnSpc>
                 <a:spcPct val="102000"/>
               </a:lnSpc>
@@ -2654,10 +2800,7 @@
         </p:spPr>
         <p:txBody>
           <a:bodyPr/>
-          <a:lstStyle/>
-          <a:p>
-            <a:endParaRPr/>
-          </a:p>
+          <a:p/>
         </p:txBody>
       </p:sp>
       <p:sp>
@@ -2681,10 +2824,7 @@
         </p:spPr>
         <p:txBody>
           <a:bodyPr/>
-          <a:lstStyle/>
-          <a:p>
-            <a:endParaRPr/>
-          </a:p>
+          <a:p/>
         </p:txBody>
       </p:sp>
       <p:sp>
@@ -2708,7 +2848,7 @@
           <a:bodyPr wrap="square" lIns="0" tIns="0" rIns="0" bIns="0" rtlCol="0" anchor="ctr"/>
           <a:lstStyle/>
           <a:p>
-            <a:pPr marL="0" indent="0">
+            <a:pPr indent="0" marL="0">
               <a:buNone/>
             </a:pPr>
             <a:r>
@@ -2747,7 +2887,7 @@
           <a:bodyPr wrap="square" lIns="0" tIns="0" rIns="0" bIns="0" rtlCol="0" anchor="t"/>
           <a:lstStyle/>
           <a:p>
-            <a:pPr marL="0" indent="0">
+            <a:pPr indent="0" marL="0">
               <a:lnSpc>
                 <a:spcPct val="102000"/>
               </a:lnSpc>
@@ -2794,10 +2934,7 @@
         </p:spPr>
         <p:txBody>
           <a:bodyPr/>
-          <a:lstStyle/>
-          <a:p>
-            <a:endParaRPr/>
-          </a:p>
+          <a:p/>
         </p:txBody>
       </p:sp>
       <p:sp>
@@ -2821,10 +2958,7 @@
         </p:spPr>
         <p:txBody>
           <a:bodyPr/>
-          <a:lstStyle/>
-          <a:p>
-            <a:endParaRPr/>
-          </a:p>
+          <a:p/>
         </p:txBody>
       </p:sp>
       <p:sp>
@@ -2848,7 +2982,7 @@
           <a:bodyPr wrap="square" lIns="0" tIns="0" rIns="0" bIns="0" rtlCol="0" anchor="ctr"/>
           <a:lstStyle/>
           <a:p>
-            <a:pPr marL="0" indent="0">
+            <a:pPr indent="0" marL="0">
               <a:buNone/>
             </a:pPr>
             <a:r>
@@ -2887,7 +3021,7 @@
           <a:bodyPr wrap="square" lIns="0" tIns="0" rIns="0" bIns="0" rtlCol="0" anchor="t"/>
           <a:lstStyle/>
           <a:p>
-            <a:pPr marL="0" indent="0">
+            <a:pPr indent="0" marL="0">
               <a:lnSpc>
                 <a:spcPct val="102000"/>
               </a:lnSpc>
@@ -2934,10 +3068,7 @@
         </p:spPr>
         <p:txBody>
           <a:bodyPr/>
-          <a:lstStyle/>
-          <a:p>
-            <a:endParaRPr/>
-          </a:p>
+          <a:p/>
         </p:txBody>
       </p:sp>
       <p:sp>
@@ -2961,10 +3092,7 @@
         </p:spPr>
         <p:txBody>
           <a:bodyPr/>
-          <a:lstStyle/>
-          <a:p>
-            <a:endParaRPr/>
-          </a:p>
+          <a:p/>
         </p:txBody>
       </p:sp>
       <p:sp>
@@ -2988,7 +3116,7 @@
           <a:bodyPr wrap="square" lIns="0" tIns="0" rIns="0" bIns="0" rtlCol="0" anchor="ctr"/>
           <a:lstStyle/>
           <a:p>
-            <a:pPr marL="0" indent="0">
+            <a:pPr indent="0" marL="0">
               <a:buNone/>
             </a:pPr>
             <a:r>
@@ -3112,7 +3240,7 @@
           <a:bodyPr wrap="square" lIns="0" tIns="0" rIns="0" bIns="0" rtlCol="0" anchor="t"/>
           <a:lstStyle/>
           <a:p>
-            <a:pPr marL="0" indent="0">
+            <a:pPr indent="0" marL="0">
               <a:lnSpc>
                 <a:spcPct val="100000"/>
               </a:lnSpc>
@@ -3154,10 +3282,7 @@
         </p:spPr>
         <p:txBody>
           <a:bodyPr/>
-          <a:lstStyle/>
-          <a:p>
-            <a:endParaRPr/>
-          </a:p>
+          <a:p/>
         </p:txBody>
       </p:sp>
       <p:sp>
@@ -3181,7 +3306,7 @@
           <a:bodyPr wrap="square" lIns="0" tIns="0" rIns="0" bIns="0" rtlCol="0" anchor="ctr"/>
           <a:lstStyle/>
           <a:p>
-            <a:pPr marL="0" indent="0" algn="ctr">
+            <a:pPr algn="ctr" indent="0" marL="0">
               <a:buNone/>
             </a:pPr>
             <a:r>
@@ -3220,7 +3345,7 @@
           <a:bodyPr wrap="square" lIns="0" tIns="0" rIns="0" bIns="0" rtlCol="0" anchor="t"/>
           <a:lstStyle/>
           <a:p>
-            <a:pPr marL="0" indent="0" algn="ctr">
+            <a:pPr algn="ctr" indent="0" marL="0">
               <a:lnSpc>
                 <a:spcPct val="105000"/>
               </a:lnSpc>
@@ -3262,7 +3387,7 @@
           <a:bodyPr wrap="square" lIns="0" tIns="0" rIns="0" bIns="0" rtlCol="0" anchor="ctr"/>
           <a:lstStyle/>
           <a:p>
-            <a:pPr marL="0" indent="0">
+            <a:pPr indent="0" marL="0">
               <a:buNone/>
             </a:pPr>
             <a:r>
@@ -3277,6 +3402,975 @@
               <a:t>Proposition de co-développement &amp; co-investissement · Mai 2026</a:t>
             </a:r>
             <a:endParaRPr lang="en-US" sz="900" dirty="0"/>
+          </a:p>
+        </p:txBody>
+      </p:sp>
+    </p:spTree>
+  </p:cSld>
+  <p:clrMapOvr>
+    <a:masterClrMapping/>
+  </p:clrMapOvr>
+</p:sld>
+</file>
+
+<file path=ppt/slides/slide11.xml><?xml version="1.0" encoding="utf-8"?>
+<p:sld xmlns:a="http://schemas.openxmlformats.org/drawingml/2006/main" xmlns:p="http://schemas.openxmlformats.org/presentationml/2006/main" xmlns:r="http://schemas.openxmlformats.org/officeDocument/2006/relationships">
+  <p:cSld>
+    <p:spTree>
+      <p:nvGrpSpPr>
+        <p:cNvPr id="1" name=""/>
+        <p:cNvGrpSpPr/>
+        <p:nvPr/>
+      </p:nvGrpSpPr>
+      <p:grpSpPr/>
+      <p:sp>
+        <p:nvSpPr>
+          <p:cNvPr id="2" name="Shape 0"/>
+          <p:cNvSpPr/>
+          <p:nvPr/>
+        </p:nvSpPr>
+        <p:spPr>
+          <a:xfrm>
+            <a:off x="457200" y="384048"/>
+            <a:ext cx="566928" cy="566928"/>
+          </a:xfrm>
+          <a:prstGeom prst="ellipse">
+            <a:avLst/>
+          </a:prstGeom>
+          <a:solidFill>
+            <a:srgbClr val="16A39A"/>
+          </a:solidFill>
+          <a:ln/>
+        </p:spPr>
+        <p:txBody>
+          <a:bodyPr/>
+          <a:p/>
+        </p:txBody>
+      </p:sp>
+      <p:sp>
+        <p:nvSpPr>
+          <p:cNvPr id="3" name="Text 1"/>
+          <p:cNvSpPr/>
+          <p:nvPr/>
+        </p:nvSpPr>
+        <p:spPr>
+          <a:xfrm>
+            <a:off x="457200" y="384048"/>
+            <a:ext cx="566928" cy="566928"/>
+          </a:xfrm>
+          <a:prstGeom prst="rect">
+            <a:avLst/>
+          </a:prstGeom>
+          <a:noFill/>
+          <a:ln/>
+        </p:spPr>
+        <p:txBody>
+          <a:bodyPr wrap="square" lIns="0" tIns="0" rIns="0" bIns="0" rtlCol="0" anchor="ctr"/>
+          <a:lstStyle/>
+          <a:p>
+            <a:pPr algn="ctr" indent="0" marL="0">
+              <a:buNone/>
+            </a:pPr>
+            <a:r>
+              <a:rPr lang="en-US" sz="2200" b="1" dirty="0">
+                <a:solidFill>
+                  <a:srgbClr val="FFFFFF"/>
+                </a:solidFill>
+                <a:latin typeface="Georgia" pitchFamily="34" charset="0"/>
+                <a:ea typeface="Georgia" pitchFamily="34" charset="-122"/>
+                <a:cs typeface="Georgia" pitchFamily="34" charset="-120"/>
+              </a:rPr>
+              <a:t/>
+            </a:r>
+            <a:endParaRPr lang="en-US" sz="2200" dirty="0"/>
+          </a:p>
+        </p:txBody>
+      </p:sp>
+      <p:sp>
+        <p:nvSpPr>
+          <p:cNvPr id="4" name="Text 2"/>
+          <p:cNvSpPr/>
+          <p:nvPr/>
+        </p:nvSpPr>
+        <p:spPr>
+          <a:xfrm>
+            <a:off x="1170432" y="384048"/>
+            <a:ext cx="10424160" cy="237744"/>
+          </a:xfrm>
+          <a:prstGeom prst="rect">
+            <a:avLst/>
+          </a:prstGeom>
+          <a:noFill/>
+          <a:ln/>
+        </p:spPr>
+        <p:txBody>
+          <a:bodyPr wrap="square" lIns="0" tIns="0" rIns="0" bIns="0" rtlCol="0" anchor="ctr"/>
+          <a:lstStyle/>
+          <a:p>
+            <a:pPr indent="0" marL="0">
+              <a:buNone/>
+            </a:pPr>
+            <a:r>
+              <a:rPr lang="en-US" sz="1100" b="1" spc="200" kern="0" dirty="0">
+                <a:solidFill>
+                  <a:srgbClr val="0E8A82"/>
+                </a:solidFill>
+                <a:latin typeface="Calibri" pitchFamily="34" charset="0"/>
+                <a:ea typeface="Calibri" pitchFamily="34" charset="-122"/>
+                <a:cs typeface="Calibri" pitchFamily="34" charset="-120"/>
+              </a:rPr>
+              <a:t>NOTRE FOCUS</a:t>
+            </a:r>
+            <a:endParaRPr lang="en-US" sz="1100" dirty="0"/>
+          </a:p>
+        </p:txBody>
+      </p:sp>
+      <p:sp>
+        <p:nvSpPr>
+          <p:cNvPr id="5" name="Text 3"/>
+          <p:cNvSpPr/>
+          <p:nvPr/>
+        </p:nvSpPr>
+        <p:spPr>
+          <a:xfrm>
+            <a:off x="1170432" y="603504"/>
+            <a:ext cx="10515600" cy="566928"/>
+          </a:xfrm>
+          <a:prstGeom prst="rect">
+            <a:avLst/>
+          </a:prstGeom>
+          <a:noFill/>
+          <a:ln/>
+        </p:spPr>
+        <p:txBody>
+          <a:bodyPr wrap="square" lIns="0" tIns="0" rIns="0" bIns="0" rtlCol="0" anchor="ctr"/>
+          <a:lstStyle/>
+          <a:p>
+            <a:pPr indent="0" marL="0">
+              <a:buNone/>
+            </a:pPr>
+            <a:r>
+              <a:rPr lang="en-US" sz="2700" b="1" dirty="0">
+                <a:solidFill>
+                  <a:srgbClr val="0E2A3B"/>
+                </a:solidFill>
+                <a:latin typeface="Georgia" pitchFamily="34" charset="0"/>
+                <a:ea typeface="Georgia" pitchFamily="34" charset="-122"/>
+                <a:cs typeface="Georgia" pitchFamily="34" charset="-120"/>
+              </a:rPr>
+              <a:t>Ce que nous sommes — et ce que nous ne sommes pas</a:t>
+            </a:r>
+            <a:endParaRPr lang="en-US" sz="2700" dirty="0"/>
+          </a:p>
+        </p:txBody>
+      </p:sp>
+      <p:sp>
+        <p:nvSpPr>
+          <p:cNvPr id="6" name="Shape 4"/>
+          <p:cNvSpPr/>
+          <p:nvPr/>
+        </p:nvSpPr>
+        <p:spPr>
+          <a:xfrm>
+            <a:off x="457200" y="1417320"/>
+            <a:ext cx="3630168" cy="2743200"/>
+          </a:xfrm>
+          <a:prstGeom prst="rect">
+            <a:avLst/>
+          </a:prstGeom>
+          <a:solidFill>
+            <a:srgbClr val="FFFFFF"/>
+          </a:solidFill>
+          <a:ln w="12700">
+            <a:solidFill>
+              <a:srgbClr val="E3DECF"/>
+            </a:solidFill>
+            <a:prstDash val="solid"/>
+          </a:ln>
+          <a:effectLst>
+            <a:outerShdw sx="100000" sy="100000" kx="0" ky="0" algn="bl" rotWithShape="0" blurRad="88900" dist="38100" dir="8100000">
+              <a:srgbClr val="0E2A3B">
+                <a:alpha val="16000"/>
+              </a:srgbClr>
+            </a:outerShdw>
+          </a:effectLst>
+        </p:spPr>
+        <p:txBody>
+          <a:bodyPr/>
+          <a:p/>
+        </p:txBody>
+      </p:sp>
+      <p:sp>
+        <p:nvSpPr>
+          <p:cNvPr id="7" name="Shape 5"/>
+          <p:cNvSpPr/>
+          <p:nvPr/>
+        </p:nvSpPr>
+        <p:spPr>
+          <a:xfrm>
+            <a:off x="457200" y="1417320"/>
+            <a:ext cx="73152" cy="2743200"/>
+          </a:xfrm>
+          <a:prstGeom prst="rect">
+            <a:avLst/>
+          </a:prstGeom>
+          <a:solidFill>
+            <a:srgbClr val="16A39A"/>
+          </a:solidFill>
+          <a:ln/>
+        </p:spPr>
+        <p:txBody>
+          <a:bodyPr/>
+          <a:p/>
+        </p:txBody>
+      </p:sp>
+      <p:sp>
+        <p:nvSpPr>
+          <p:cNvPr id="8" name="Text 6"/>
+          <p:cNvSpPr/>
+          <p:nvPr/>
+        </p:nvSpPr>
+        <p:spPr>
+          <a:xfrm>
+            <a:off x="658368" y="1545336"/>
+            <a:ext cx="3264408" cy="365760"/>
+          </a:xfrm>
+          <a:prstGeom prst="rect">
+            <a:avLst/>
+          </a:prstGeom>
+          <a:noFill/>
+          <a:ln/>
+        </p:spPr>
+        <p:txBody>
+          <a:bodyPr wrap="square" lIns="0" tIns="0" rIns="0" bIns="0" rtlCol="0" anchor="t"/>
+          <a:lstStyle/>
+          <a:p>
+            <a:pPr indent="0" marL="0">
+              <a:buNone/>
+            </a:pPr>
+            <a:r>
+              <a:rPr lang="en-US" sz="1400" b="1" dirty="0">
+                <a:solidFill>
+                  <a:srgbClr val="0E2A3B"/>
+                </a:solidFill>
+                <a:latin typeface="Georgia" pitchFamily="34" charset="0"/>
+                <a:ea typeface="Georgia" pitchFamily="34" charset="-122"/>
+                <a:cs typeface="Georgia" pitchFamily="34" charset="-120"/>
+              </a:rPr>
+              <a:t>Ce que nous SOMMES</a:t>
+            </a:r>
+            <a:endParaRPr lang="en-US" sz="1400" dirty="0"/>
+          </a:p>
+        </p:txBody>
+      </p:sp>
+      <p:sp>
+        <p:nvSpPr>
+          <p:cNvPr id="9" name="Text 7"/>
+          <p:cNvSpPr/>
+          <p:nvPr/>
+        </p:nvSpPr>
+        <p:spPr>
+          <a:xfrm>
+            <a:off x="676656" y="1929384"/>
+            <a:ext cx="3227832" cy="2139696"/>
+          </a:xfrm>
+          <a:prstGeom prst="rect">
+            <a:avLst/>
+          </a:prstGeom>
+          <a:noFill/>
+          <a:ln/>
+        </p:spPr>
+        <p:txBody>
+          <a:bodyPr wrap="square" lIns="0" tIns="0" rIns="0" bIns="0" rtlCol="0" anchor="t"/>
+          <a:lstStyle/>
+          <a:p>
+            <a:pPr marL="152400" indent="-152400">
+              <a:lnSpc>
+                <a:spcPct val="102000"/>
+              </a:lnSpc>
+              <a:spcAft>
+                <a:spcPts val="300"/>
+              </a:spcAft>
+              <a:buSzPct val="100000"/>
+              <a:buChar char="•"/>
+            </a:pPr>
+            <a:r>
+              <a:rPr lang="en-US" sz="1050" dirty="0">
+                <a:solidFill>
+                  <a:srgbClr val="1F2D36"/>
+                </a:solidFill>
+                <a:latin typeface="Calibri" pitchFamily="34" charset="0"/>
+                <a:ea typeface="Calibri" pitchFamily="34" charset="-122"/>
+                <a:cs typeface="Calibri" pitchFamily="34" charset="-120"/>
+              </a:rPr>
+              <a:t>La plateforme SaaS qui orchestre plusieurs marques de matériel</a:t>
+            </a:r>
+            <a:endParaRPr lang="en-US" sz="1050" dirty="0"/>
+          </a:p>
+          <a:p>
+            <a:pPr marL="152400" indent="-152400">
+              <a:lnSpc>
+                <a:spcPct val="102000"/>
+              </a:lnSpc>
+              <a:spcAft>
+                <a:spcPts val="300"/>
+              </a:spcAft>
+              <a:buSzPct val="100000"/>
+              <a:buChar char="•"/>
+            </a:pPr>
+            <a:r>
+              <a:rPr lang="en-US" sz="1050" dirty="0">
+                <a:solidFill>
+                  <a:srgbClr val="1F2D36"/>
+                </a:solidFill>
+                <a:latin typeface="Calibri" pitchFamily="34" charset="0"/>
+                <a:ea typeface="Calibri" pitchFamily="34" charset="-122"/>
+                <a:cs typeface="Calibri" pitchFamily="34" charset="-120"/>
+              </a:rPr>
+              <a:t>Le vertical tourisme : app client, occupation, ESG, labels</a:t>
+            </a:r>
+            <a:endParaRPr lang="en-US" sz="1050" dirty="0"/>
+          </a:p>
+          <a:p>
+            <a:pPr marL="152400" indent="-152400">
+              <a:lnSpc>
+                <a:spcPct val="102000"/>
+              </a:lnSpc>
+              <a:spcAft>
+                <a:spcPts val="300"/>
+              </a:spcAft>
+              <a:buSzPct val="100000"/>
+              <a:buChar char="•"/>
+            </a:pPr>
+            <a:r>
+              <a:rPr lang="en-US" sz="1050" dirty="0">
+                <a:solidFill>
+                  <a:srgbClr val="1F2D36"/>
+                </a:solidFill>
+                <a:latin typeface="Calibri" pitchFamily="34" charset="0"/>
+                <a:ea typeface="Calibri" pitchFamily="34" charset="-122"/>
+                <a:cs typeface="Calibri" pitchFamily="34" charset="-120"/>
+              </a:rPr>
+              <a:t>L’accès distribution aux campings via l’écosystème COREPROMA</a:t>
+            </a:r>
+            <a:endParaRPr lang="en-US" sz="1050" dirty="0"/>
+          </a:p>
+        </p:txBody>
+      </p:sp>
+      <p:sp>
+        <p:nvSpPr>
+          <p:cNvPr id="10" name="Shape 8"/>
+          <p:cNvSpPr/>
+          <p:nvPr/>
+        </p:nvSpPr>
+        <p:spPr>
+          <a:xfrm>
+            <a:off x="4270248" y="1417320"/>
+            <a:ext cx="3630168" cy="2743200"/>
+          </a:xfrm>
+          <a:prstGeom prst="rect">
+            <a:avLst/>
+          </a:prstGeom>
+          <a:solidFill>
+            <a:srgbClr val="FFFFFF"/>
+          </a:solidFill>
+          <a:ln w="12700">
+            <a:solidFill>
+              <a:srgbClr val="E3DECF"/>
+            </a:solidFill>
+            <a:prstDash val="solid"/>
+          </a:ln>
+          <a:effectLst>
+            <a:outerShdw sx="100000" sy="100000" kx="0" ky="0" algn="bl" rotWithShape="0" blurRad="88900" dist="38100" dir="8100000">
+              <a:srgbClr val="0E2A3B">
+                <a:alpha val="16000"/>
+              </a:srgbClr>
+            </a:outerShdw>
+          </a:effectLst>
+        </p:spPr>
+        <p:txBody>
+          <a:bodyPr/>
+          <a:p/>
+        </p:txBody>
+      </p:sp>
+      <p:sp>
+        <p:nvSpPr>
+          <p:cNvPr id="11" name="Shape 9"/>
+          <p:cNvSpPr/>
+          <p:nvPr/>
+        </p:nvSpPr>
+        <p:spPr>
+          <a:xfrm>
+            <a:off x="4270248" y="1417320"/>
+            <a:ext cx="73152" cy="2743200"/>
+          </a:xfrm>
+          <a:prstGeom prst="rect">
+            <a:avLst/>
+          </a:prstGeom>
+          <a:solidFill>
+            <a:srgbClr val="4CA66B"/>
+          </a:solidFill>
+          <a:ln/>
+        </p:spPr>
+        <p:txBody>
+          <a:bodyPr/>
+          <a:p/>
+        </p:txBody>
+      </p:sp>
+      <p:sp>
+        <p:nvSpPr>
+          <p:cNvPr id="12" name="Text 10"/>
+          <p:cNvSpPr/>
+          <p:nvPr/>
+        </p:nvSpPr>
+        <p:spPr>
+          <a:xfrm>
+            <a:off x="4471416" y="1545336"/>
+            <a:ext cx="3264408" cy="365760"/>
+          </a:xfrm>
+          <a:prstGeom prst="rect">
+            <a:avLst/>
+          </a:prstGeom>
+          <a:noFill/>
+          <a:ln/>
+        </p:spPr>
+        <p:txBody>
+          <a:bodyPr wrap="square" lIns="0" tIns="0" rIns="0" bIns="0" rtlCol="0" anchor="t"/>
+          <a:lstStyle/>
+          <a:p>
+            <a:pPr indent="0" marL="0">
+              <a:buNone/>
+            </a:pPr>
+            <a:r>
+              <a:rPr lang="en-US" sz="1400" b="1" dirty="0">
+                <a:solidFill>
+                  <a:srgbClr val="0E2A3B"/>
+                </a:solidFill>
+                <a:latin typeface="Georgia" pitchFamily="34" charset="0"/>
+                <a:ea typeface="Georgia" pitchFamily="34" charset="-122"/>
+                <a:cs typeface="Georgia" pitchFamily="34" charset="-120"/>
+              </a:rPr>
+              <a:t>Ce que nous NE sommes PAS</a:t>
+            </a:r>
+            <a:endParaRPr lang="en-US" sz="1400" dirty="0"/>
+          </a:p>
+        </p:txBody>
+      </p:sp>
+      <p:sp>
+        <p:nvSpPr>
+          <p:cNvPr id="13" name="Text 11"/>
+          <p:cNvSpPr/>
+          <p:nvPr/>
+        </p:nvSpPr>
+        <p:spPr>
+          <a:xfrm>
+            <a:off x="4489704" y="1929384"/>
+            <a:ext cx="3227832" cy="2139696"/>
+          </a:xfrm>
+          <a:prstGeom prst="rect">
+            <a:avLst/>
+          </a:prstGeom>
+          <a:noFill/>
+          <a:ln/>
+        </p:spPr>
+        <p:txBody>
+          <a:bodyPr wrap="square" lIns="0" tIns="0" rIns="0" bIns="0" rtlCol="0" anchor="t"/>
+          <a:lstStyle/>
+          <a:p>
+            <a:pPr marL="152400" indent="-152400">
+              <a:lnSpc>
+                <a:spcPct val="102000"/>
+              </a:lnSpc>
+              <a:spcAft>
+                <a:spcPts val="300"/>
+              </a:spcAft>
+              <a:buSzPct val="100000"/>
+              <a:buChar char="•"/>
+            </a:pPr>
+            <a:r>
+              <a:rPr lang="en-US" sz="1050" dirty="0">
+                <a:solidFill>
+                  <a:srgbClr val="1F2D36"/>
+                </a:solidFill>
+                <a:latin typeface="Calibri" pitchFamily="34" charset="0"/>
+                <a:ea typeface="Calibri" pitchFamily="34" charset="-122"/>
+                <a:cs typeface="Calibri" pitchFamily="34" charset="-120"/>
+              </a:rPr>
+              <a:t>Un fabricant de matériel (onduleurs, batteries)</a:t>
+            </a:r>
+            <a:endParaRPr lang="en-US" sz="1050" dirty="0"/>
+          </a:p>
+          <a:p>
+            <a:pPr marL="152400" indent="-152400">
+              <a:lnSpc>
+                <a:spcPct val="102000"/>
+              </a:lnSpc>
+              <a:spcAft>
+                <a:spcPts val="300"/>
+              </a:spcAft>
+              <a:buSzPct val="100000"/>
+              <a:buChar char="•"/>
+            </a:pPr>
+            <a:r>
+              <a:rPr lang="en-US" sz="1050" dirty="0">
+                <a:solidFill>
+                  <a:srgbClr val="1F2D36"/>
+                </a:solidFill>
+                <a:latin typeface="Calibri" pitchFamily="34" charset="0"/>
+                <a:ea typeface="Calibri" pitchFamily="34" charset="-122"/>
+                <a:cs typeface="Calibri" pitchFamily="34" charset="-120"/>
+              </a:rPr>
+              <a:t>Un simple EMS d’onduleur — c’est une commodité</a:t>
+            </a:r>
+            <a:endParaRPr lang="en-US" sz="1050" dirty="0"/>
+          </a:p>
+          <a:p>
+            <a:pPr marL="152400" indent="-152400">
+              <a:lnSpc>
+                <a:spcPct val="102000"/>
+              </a:lnSpc>
+              <a:spcAft>
+                <a:spcPts val="300"/>
+              </a:spcAft>
+              <a:buSzPct val="100000"/>
+              <a:buChar char="•"/>
+            </a:pPr>
+            <a:r>
+              <a:rPr lang="en-US" sz="1050" dirty="0">
+                <a:solidFill>
+                  <a:srgbClr val="1F2D36"/>
+                </a:solidFill>
+                <a:latin typeface="Calibri" pitchFamily="34" charset="0"/>
+                <a:ea typeface="Calibri" pitchFamily="34" charset="-122"/>
+                <a:cs typeface="Calibri" pitchFamily="34" charset="-120"/>
+              </a:rPr>
+              <a:t>Verrouillé à une seule marque</a:t>
+            </a:r>
+            <a:endParaRPr lang="en-US" sz="1050" dirty="0"/>
+          </a:p>
+        </p:txBody>
+      </p:sp>
+      <p:sp>
+        <p:nvSpPr>
+          <p:cNvPr id="14" name="Shape 12"/>
+          <p:cNvSpPr/>
+          <p:nvPr/>
+        </p:nvSpPr>
+        <p:spPr>
+          <a:xfrm>
+            <a:off x="8083296" y="1417320"/>
+            <a:ext cx="3621024" cy="2743200"/>
+          </a:xfrm>
+          <a:prstGeom prst="rect">
+            <a:avLst/>
+          </a:prstGeom>
+          <a:solidFill>
+            <a:srgbClr val="FFFFFF"/>
+          </a:solidFill>
+          <a:ln w="12700">
+            <a:solidFill>
+              <a:srgbClr val="E3DECF"/>
+            </a:solidFill>
+            <a:prstDash val="solid"/>
+          </a:ln>
+          <a:effectLst>
+            <a:outerShdw sx="100000" sy="100000" kx="0" ky="0" algn="bl" rotWithShape="0" blurRad="88900" dist="38100" dir="8100000">
+              <a:srgbClr val="0E2A3B">
+                <a:alpha val="16000"/>
+              </a:srgbClr>
+            </a:outerShdw>
+          </a:effectLst>
+        </p:spPr>
+        <p:txBody>
+          <a:bodyPr/>
+          <a:p/>
+        </p:txBody>
+      </p:sp>
+      <p:sp>
+        <p:nvSpPr>
+          <p:cNvPr id="15" name="Shape 13"/>
+          <p:cNvSpPr/>
+          <p:nvPr/>
+        </p:nvSpPr>
+        <p:spPr>
+          <a:xfrm>
+            <a:off x="8083296" y="1417320"/>
+            <a:ext cx="73152" cy="2743200"/>
+          </a:xfrm>
+          <a:prstGeom prst="rect">
+            <a:avLst/>
+          </a:prstGeom>
+          <a:solidFill>
+            <a:srgbClr val="E8A23D"/>
+          </a:solidFill>
+          <a:ln/>
+        </p:spPr>
+        <p:txBody>
+          <a:bodyPr/>
+          <a:p/>
+        </p:txBody>
+      </p:sp>
+      <p:sp>
+        <p:nvSpPr>
+          <p:cNvPr id="16" name="Text 14"/>
+          <p:cNvSpPr/>
+          <p:nvPr/>
+        </p:nvSpPr>
+        <p:spPr>
+          <a:xfrm>
+            <a:off x="8284464" y="1545336"/>
+            <a:ext cx="3255264" cy="365760"/>
+          </a:xfrm>
+          <a:prstGeom prst="rect">
+            <a:avLst/>
+          </a:prstGeom>
+          <a:noFill/>
+          <a:ln/>
+        </p:spPr>
+        <p:txBody>
+          <a:bodyPr wrap="square" lIns="0" tIns="0" rIns="0" bIns="0" rtlCol="0" anchor="t"/>
+          <a:lstStyle/>
+          <a:p>
+            <a:pPr indent="0" marL="0">
+              <a:buNone/>
+            </a:pPr>
+            <a:r>
+              <a:rPr lang="en-US" sz="1400" b="1" dirty="0">
+                <a:solidFill>
+                  <a:srgbClr val="0E2A3B"/>
+                </a:solidFill>
+                <a:latin typeface="Georgia" pitchFamily="34" charset="0"/>
+                <a:ea typeface="Georgia" pitchFamily="34" charset="-122"/>
+                <a:cs typeface="Georgia" pitchFamily="34" charset="-120"/>
+              </a:rPr>
+              <a:t>Notre fossé</a:t>
+            </a:r>
+            <a:endParaRPr lang="en-US" sz="1400" dirty="0"/>
+          </a:p>
+        </p:txBody>
+      </p:sp>
+      <p:sp>
+        <p:nvSpPr>
+          <p:cNvPr id="17" name="Text 15"/>
+          <p:cNvSpPr/>
+          <p:nvPr/>
+        </p:nvSpPr>
+        <p:spPr>
+          <a:xfrm>
+            <a:off x="8302752" y="1929384"/>
+            <a:ext cx="3218688" cy="2139696"/>
+          </a:xfrm>
+          <a:prstGeom prst="rect">
+            <a:avLst/>
+          </a:prstGeom>
+          <a:noFill/>
+          <a:ln/>
+        </p:spPr>
+        <p:txBody>
+          <a:bodyPr wrap="square" lIns="0" tIns="0" rIns="0" bIns="0" rtlCol="0" anchor="t"/>
+          <a:lstStyle/>
+          <a:p>
+            <a:pPr marL="152400" indent="-152400">
+              <a:lnSpc>
+                <a:spcPct val="102000"/>
+              </a:lnSpc>
+              <a:spcAft>
+                <a:spcPts val="300"/>
+              </a:spcAft>
+              <a:buSzPct val="100000"/>
+              <a:buChar char="•"/>
+            </a:pPr>
+            <a:r>
+              <a:rPr lang="en-US" sz="1050" dirty="0">
+                <a:solidFill>
+                  <a:srgbClr val="1F2D36"/>
+                </a:solidFill>
+                <a:latin typeface="Calibri" pitchFamily="34" charset="0"/>
+                <a:ea typeface="Calibri" pitchFamily="34" charset="-122"/>
+                <a:cs typeface="Calibri" pitchFamily="34" charset="-120"/>
+              </a:rPr>
+              <a:t>Distribution : accès déjà existant au segment</a:t>
+            </a:r>
+            <a:endParaRPr lang="en-US" sz="1050" dirty="0"/>
+          </a:p>
+          <a:p>
+            <a:pPr marL="152400" indent="-152400">
+              <a:lnSpc>
+                <a:spcPct val="102000"/>
+              </a:lnSpc>
+              <a:spcAft>
+                <a:spcPts val="300"/>
+              </a:spcAft>
+              <a:buSzPct val="100000"/>
+              <a:buChar char="•"/>
+            </a:pPr>
+            <a:r>
+              <a:rPr lang="en-US" sz="1050" dirty="0">
+                <a:solidFill>
+                  <a:srgbClr val="1F2D36"/>
+                </a:solidFill>
+                <a:latin typeface="Calibri" pitchFamily="34" charset="0"/>
+                <a:ea typeface="Calibri" pitchFamily="34" charset="-122"/>
+                <a:cs typeface="Calibri" pitchFamily="34" charset="-120"/>
+              </a:rPr>
+              <a:t>Donnée d’occupation (réservations) → prévision de charge IA</a:t>
+            </a:r>
+            <a:endParaRPr lang="en-US" sz="1050" dirty="0"/>
+          </a:p>
+          <a:p>
+            <a:pPr marL="152400" indent="-152400">
+              <a:lnSpc>
+                <a:spcPct val="102000"/>
+              </a:lnSpc>
+              <a:spcAft>
+                <a:spcPts val="300"/>
+              </a:spcAft>
+              <a:buSzPct val="100000"/>
+              <a:buChar char="•"/>
+            </a:pPr>
+            <a:r>
+              <a:rPr lang="en-US" sz="1050" dirty="0">
+                <a:solidFill>
+                  <a:srgbClr val="1F2D36"/>
+                </a:solidFill>
+                <a:latin typeface="Calibri" pitchFamily="34" charset="0"/>
+                <a:ea typeface="Calibri" pitchFamily="34" charset="-122"/>
+                <a:cs typeface="Calibri" pitchFamily="34" charset="-120"/>
+              </a:rPr>
+              <a:t>Orchestration multi-marques + couche tourisme / ESG</a:t>
+            </a:r>
+            <a:endParaRPr lang="en-US" sz="1050" dirty="0"/>
+          </a:p>
+        </p:txBody>
+      </p:sp>
+      <p:sp>
+        <p:nvSpPr>
+          <p:cNvPr id="18" name="Shape 16"/>
+          <p:cNvSpPr/>
+          <p:nvPr/>
+        </p:nvSpPr>
+        <p:spPr>
+          <a:xfrm>
+            <a:off x="457200" y="4370832"/>
+            <a:ext cx="11247120" cy="1051560"/>
+          </a:xfrm>
+          <a:prstGeom prst="rect">
+            <a:avLst/>
+          </a:prstGeom>
+          <a:solidFill>
+            <a:srgbClr val="0E2A3B"/>
+          </a:solidFill>
+          <a:ln/>
+        </p:spPr>
+        <p:txBody>
+          <a:bodyPr/>
+          <a:p/>
+        </p:txBody>
+      </p:sp>
+      <p:sp>
+        <p:nvSpPr>
+          <p:cNvPr id="19" name="Shape 17"/>
+          <p:cNvSpPr/>
+          <p:nvPr/>
+        </p:nvSpPr>
+        <p:spPr>
+          <a:xfrm>
+            <a:off x="457200" y="4370832"/>
+            <a:ext cx="91440" cy="1051560"/>
+          </a:xfrm>
+          <a:prstGeom prst="rect">
+            <a:avLst/>
+          </a:prstGeom>
+          <a:solidFill>
+            <a:srgbClr val="E8A23D"/>
+          </a:solidFill>
+          <a:ln/>
+        </p:spPr>
+        <p:txBody>
+          <a:bodyPr/>
+          <a:p/>
+        </p:txBody>
+      </p:sp>
+      <p:sp>
+        <p:nvSpPr>
+          <p:cNvPr id="20" name="Text 18"/>
+          <p:cNvSpPr/>
+          <p:nvPr/>
+        </p:nvSpPr>
+        <p:spPr>
+          <a:xfrm>
+            <a:off x="713232" y="4480560"/>
+            <a:ext cx="10881360" cy="274320"/>
+          </a:xfrm>
+          <a:prstGeom prst="rect">
+            <a:avLst/>
+          </a:prstGeom>
+          <a:noFill/>
+          <a:ln/>
+        </p:spPr>
+        <p:txBody>
+          <a:bodyPr wrap="square" lIns="0" tIns="0" rIns="0" bIns="0" rtlCol="0" anchor="ctr"/>
+          <a:lstStyle/>
+          <a:p>
+            <a:pPr indent="0" marL="0">
+              <a:buNone/>
+            </a:pPr>
+            <a:r>
+              <a:rPr lang="en-US" sz="1300" b="1" dirty="0">
+                <a:solidFill>
+                  <a:srgbClr val="63E0D2"/>
+                </a:solidFill>
+                <a:latin typeface="Georgia" pitchFamily="34" charset="0"/>
+                <a:ea typeface="Georgia" pitchFamily="34" charset="-122"/>
+                <a:cs typeface="Georgia" pitchFamily="34" charset="-120"/>
+              </a:rPr>
+              <a:t>En clair</a:t>
+            </a:r>
+            <a:endParaRPr lang="en-US" sz="1300" dirty="0"/>
+          </a:p>
+        </p:txBody>
+      </p:sp>
+      <p:sp>
+        <p:nvSpPr>
+          <p:cNvPr id="21" name="Text 19"/>
+          <p:cNvSpPr/>
+          <p:nvPr/>
+        </p:nvSpPr>
+        <p:spPr>
+          <a:xfrm>
+            <a:off x="713232" y="4754880"/>
+            <a:ext cx="10881360" cy="621792"/>
+          </a:xfrm>
+          <a:prstGeom prst="rect">
+            <a:avLst/>
+          </a:prstGeom>
+          <a:noFill/>
+          <a:ln/>
+        </p:spPr>
+        <p:txBody>
+          <a:bodyPr wrap="square" lIns="0" tIns="0" rIns="0" bIns="0" rtlCol="0" anchor="t"/>
+          <a:lstStyle/>
+          <a:p>
+            <a:pPr indent="0" marL="0">
+              <a:lnSpc>
+                <a:spcPct val="104000"/>
+              </a:lnSpc>
+              <a:buNone/>
+            </a:pPr>
+            <a:r>
+              <a:rPr lang="en-US" sz="1100" dirty="0">
+                <a:solidFill>
+                  <a:srgbClr val="DCE7EB"/>
+                </a:solidFill>
+                <a:latin typeface="Calibri" pitchFamily="34" charset="0"/>
+                <a:ea typeface="Calibri" pitchFamily="34" charset="-122"/>
+                <a:cs typeface="Calibri" pitchFamily="34" charset="-120"/>
+              </a:rPr>
+              <a:t>FoxESS, SolarEdge, Huawei, OCPP… = matériel et sources de données intégrés. ECOGRID est la couche logicielle au-dessus : agnostique du matériel, branchée sur le tourisme et la distribution COREPROMA.</a:t>
+            </a:r>
+            <a:endParaRPr lang="en-US" sz="1100" dirty="0"/>
+          </a:p>
+        </p:txBody>
+      </p:sp>
+      <p:sp>
+        <p:nvSpPr>
+          <p:cNvPr id="22" name="Shape 20"/>
+          <p:cNvSpPr/>
+          <p:nvPr/>
+        </p:nvSpPr>
+        <p:spPr>
+          <a:xfrm>
+            <a:off x="0" y="6547104"/>
+            <a:ext cx="12161520" cy="310896"/>
+          </a:xfrm>
+          <a:prstGeom prst="rect">
+            <a:avLst/>
+          </a:prstGeom>
+          <a:solidFill>
+            <a:srgbClr val="0E2A3B"/>
+          </a:solidFill>
+          <a:ln/>
+        </p:spPr>
+        <p:txBody>
+          <a:bodyPr/>
+          <a:p/>
+        </p:txBody>
+      </p:sp>
+      <p:sp>
+        <p:nvSpPr>
+          <p:cNvPr id="23" name="Text 21"/>
+          <p:cNvSpPr/>
+          <p:nvPr/>
+        </p:nvSpPr>
+        <p:spPr>
+          <a:xfrm>
+            <a:off x="457200" y="6547104"/>
+            <a:ext cx="6400800" cy="310896"/>
+          </a:xfrm>
+          <a:prstGeom prst="rect">
+            <a:avLst/>
+          </a:prstGeom>
+          <a:noFill/>
+          <a:ln/>
+        </p:spPr>
+        <p:txBody>
+          <a:bodyPr wrap="square" lIns="0" tIns="0" rIns="0" bIns="0" rtlCol="0" anchor="ctr"/>
+          <a:lstStyle/>
+          <a:p>
+            <a:pPr indent="0" marL="0">
+              <a:buNone/>
+            </a:pPr>
+            <a:r>
+              <a:rPr lang="en-US" sz="850" dirty="0">
+                <a:solidFill>
+                  <a:srgbClr val="9FB3BD"/>
+                </a:solidFill>
+                <a:latin typeface="Calibri" pitchFamily="34" charset="0"/>
+                <a:ea typeface="Calibri" pitchFamily="34" charset="-122"/>
+                <a:cs typeface="Calibri" pitchFamily="34" charset="-120"/>
+              </a:rPr>
+              <a:t>ECOGRID RESORT™</a:t>
+            </a:r>
+            <a:endParaRPr lang="en-US" sz="850" dirty="0"/>
+          </a:p>
+        </p:txBody>
+      </p:sp>
+      <p:sp>
+        <p:nvSpPr>
+          <p:cNvPr id="24" name="Text 22"/>
+          <p:cNvSpPr/>
+          <p:nvPr/>
+        </p:nvSpPr>
+        <p:spPr>
+          <a:xfrm>
+            <a:off x="5486400" y="6547104"/>
+            <a:ext cx="6217920" cy="310896"/>
+          </a:xfrm>
+          <a:prstGeom prst="rect">
+            <a:avLst/>
+          </a:prstGeom>
+          <a:noFill/>
+          <a:ln/>
+        </p:spPr>
+        <p:txBody>
+          <a:bodyPr wrap="square" lIns="0" tIns="0" rIns="0" bIns="0" rtlCol="0" anchor="ctr"/>
+          <a:lstStyle/>
+          <a:p>
+            <a:pPr algn="r" indent="0" marL="0">
+              <a:buNone/>
+            </a:pPr>
+            <a:r>
+              <a:rPr lang="en-US" sz="850" dirty="0">
+                <a:solidFill>
+                  <a:srgbClr val="9FB3BD"/>
+                </a:solidFill>
+                <a:latin typeface="Calibri" pitchFamily="34" charset="0"/>
+                <a:ea typeface="Calibri" pitchFamily="34" charset="-122"/>
+                <a:cs typeface="Calibri" pitchFamily="34" charset="-120"/>
+              </a:rPr>
+              <a:t>Proposition de co-développement &amp; co-investissement · Mai 2026</a:t>
+            </a:r>
+            <a:endParaRPr lang="en-US" sz="850" dirty="0"/>
           </a:p>
         </p:txBody>
       </p:sp>
@@ -3296,7 +4390,6 @@
         <a:solidFill>
           <a:srgbClr val="F4F0E8"/>
         </a:solidFill>
-        <a:effectLst/>
       </p:bgPr>
     </p:bg>
     <p:spTree>
@@ -3334,10 +4427,7 @@
         </p:spPr>
         <p:txBody>
           <a:bodyPr/>
-          <a:lstStyle/>
-          <a:p>
-            <a:endParaRPr/>
-          </a:p>
+          <a:p/>
         </p:txBody>
       </p:sp>
       <p:sp>
@@ -3361,7 +4451,7 @@
           <a:bodyPr wrap="square" lIns="0" tIns="0" rIns="0" bIns="0" rtlCol="0" anchor="ctr"/>
           <a:lstStyle/>
           <a:p>
-            <a:pPr marL="0" indent="0" algn="ctr">
+            <a:pPr algn="ctr" indent="0" marL="0">
               <a:buNone/>
             </a:pPr>
             <a:r>
@@ -3400,11 +4490,11 @@
           <a:bodyPr wrap="square" lIns="0" tIns="0" rIns="0" bIns="0" rtlCol="0" anchor="ctr"/>
           <a:lstStyle/>
           <a:p>
-            <a:pPr marL="0" indent="0">
+            <a:pPr indent="0" marL="0">
               <a:buNone/>
             </a:pPr>
             <a:r>
-              <a:rPr lang="en-US" sz="1100" b="1" kern="0" spc="200" dirty="0">
+              <a:rPr lang="en-US" sz="1100" b="1" spc="200" kern="0" dirty="0">
                 <a:solidFill>
                   <a:srgbClr val="0E8A82"/>
                 </a:solidFill>
@@ -3439,7 +4529,7 @@
           <a:bodyPr wrap="square" lIns="0" tIns="0" rIns="0" bIns="0" rtlCol="0" anchor="ctr"/>
           <a:lstStyle/>
           <a:p>
-            <a:pPr marL="0" indent="0">
+            <a:pPr indent="0" marL="0">
               <a:buNone/>
             </a:pPr>
             <a:r>
@@ -3478,7 +4568,7 @@
           <a:bodyPr wrap="square" lIns="0" tIns="0" rIns="0" bIns="0" rtlCol="0" anchor="ctr"/>
           <a:lstStyle/>
           <a:p>
-            <a:pPr marL="0" indent="0">
+            <a:pPr indent="0" marL="0">
               <a:lnSpc>
                 <a:spcPct val="105000"/>
               </a:lnSpc>
@@ -3523,7 +4613,7 @@
             <a:prstDash val="solid"/>
           </a:ln>
           <a:effectLst>
-            <a:outerShdw blurRad="88900" dist="38100" dir="8100000" algn="bl" rotWithShape="0">
+            <a:outerShdw sx="100000" sy="100000" kx="0" ky="0" algn="bl" rotWithShape="0" blurRad="88900" dist="38100" dir="8100000">
               <a:srgbClr val="0E2A3B">
                 <a:alpha val="16000"/>
               </a:srgbClr>
@@ -3532,10 +4622,7 @@
         </p:spPr>
         <p:txBody>
           <a:bodyPr/>
-          <a:lstStyle/>
-          <a:p>
-            <a:endParaRPr/>
-          </a:p>
+          <a:p/>
         </p:txBody>
       </p:sp>
       <p:sp>
@@ -3559,10 +4646,7 @@
         </p:spPr>
         <p:txBody>
           <a:bodyPr/>
-          <a:lstStyle/>
-          <a:p>
-            <a:endParaRPr/>
-          </a:p>
+          <a:p/>
         </p:txBody>
       </p:sp>
       <p:sp>
@@ -3586,7 +4670,7 @@
           <a:bodyPr wrap="square" lIns="0" tIns="0" rIns="0" bIns="0" rtlCol="0" anchor="t"/>
           <a:lstStyle/>
           <a:p>
-            <a:pPr marL="0" indent="0">
+            <a:pPr indent="0" marL="0">
               <a:buNone/>
             </a:pPr>
             <a:r>
@@ -3698,7 +4782,7 @@
             <a:prstDash val="solid"/>
           </a:ln>
           <a:effectLst>
-            <a:outerShdw blurRad="88900" dist="38100" dir="8100000" algn="bl" rotWithShape="0">
+            <a:outerShdw sx="100000" sy="100000" kx="0" ky="0" algn="bl" rotWithShape="0" blurRad="88900" dist="38100" dir="8100000">
               <a:srgbClr val="0E2A3B">
                 <a:alpha val="16000"/>
               </a:srgbClr>
@@ -3707,10 +4791,7 @@
         </p:spPr>
         <p:txBody>
           <a:bodyPr/>
-          <a:lstStyle/>
-          <a:p>
-            <a:endParaRPr/>
-          </a:p>
+          <a:p/>
         </p:txBody>
       </p:sp>
       <p:sp>
@@ -3734,10 +4815,7 @@
         </p:spPr>
         <p:txBody>
           <a:bodyPr/>
-          <a:lstStyle/>
-          <a:p>
-            <a:endParaRPr/>
-          </a:p>
+          <a:p/>
         </p:txBody>
       </p:sp>
       <p:sp>
@@ -3761,7 +4839,7 @@
           <a:bodyPr wrap="square" lIns="0" tIns="0" rIns="0" bIns="0" rtlCol="0" anchor="t"/>
           <a:lstStyle/>
           <a:p>
-            <a:pPr marL="0" indent="0">
+            <a:pPr indent="0" marL="0">
               <a:buNone/>
             </a:pPr>
             <a:r>
@@ -3873,7 +4951,7 @@
             <a:prstDash val="solid"/>
           </a:ln>
           <a:effectLst>
-            <a:outerShdw blurRad="88900" dist="38100" dir="8100000" algn="bl" rotWithShape="0">
+            <a:outerShdw sx="100000" sy="100000" kx="0" ky="0" algn="bl" rotWithShape="0" blurRad="88900" dist="38100" dir="8100000">
               <a:srgbClr val="0E2A3B">
                 <a:alpha val="16000"/>
               </a:srgbClr>
@@ -3882,10 +4960,7 @@
         </p:spPr>
         <p:txBody>
           <a:bodyPr/>
-          <a:lstStyle/>
-          <a:p>
-            <a:endParaRPr/>
-          </a:p>
+          <a:p/>
         </p:txBody>
       </p:sp>
       <p:sp>
@@ -3909,10 +4984,7 @@
         </p:spPr>
         <p:txBody>
           <a:bodyPr/>
-          <a:lstStyle/>
-          <a:p>
-            <a:endParaRPr/>
-          </a:p>
+          <a:p/>
         </p:txBody>
       </p:sp>
       <p:sp>
@@ -3936,7 +5008,7 @@
           <a:bodyPr wrap="square" lIns="0" tIns="0" rIns="0" bIns="0" rtlCol="0" anchor="t"/>
           <a:lstStyle/>
           <a:p>
-            <a:pPr marL="0" indent="0">
+            <a:pPr indent="0" marL="0">
               <a:buNone/>
             </a:pPr>
             <a:r>
@@ -4048,7 +5120,7 @@
             <a:prstDash val="solid"/>
           </a:ln>
           <a:effectLst>
-            <a:outerShdw blurRad="88900" dist="38100" dir="8100000" algn="bl" rotWithShape="0">
+            <a:outerShdw sx="100000" sy="100000" kx="0" ky="0" algn="bl" rotWithShape="0" blurRad="88900" dist="38100" dir="8100000">
               <a:srgbClr val="0E2A3B">
                 <a:alpha val="16000"/>
               </a:srgbClr>
@@ -4057,10 +5129,7 @@
         </p:spPr>
         <p:txBody>
           <a:bodyPr/>
-          <a:lstStyle/>
-          <a:p>
-            <a:endParaRPr/>
-          </a:p>
+          <a:p/>
         </p:txBody>
       </p:sp>
       <p:sp>
@@ -4084,10 +5153,7 @@
         </p:spPr>
         <p:txBody>
           <a:bodyPr/>
-          <a:lstStyle/>
-          <a:p>
-            <a:endParaRPr/>
-          </a:p>
+          <a:p/>
         </p:txBody>
       </p:sp>
       <p:sp>
@@ -4111,7 +5177,7 @@
           <a:bodyPr wrap="square" lIns="0" tIns="0" rIns="0" bIns="0" rtlCol="0" anchor="t"/>
           <a:lstStyle/>
           <a:p>
-            <a:pPr marL="0" indent="0">
+            <a:pPr indent="0" marL="0">
               <a:buNone/>
             </a:pPr>
             <a:r>
@@ -4220,10 +5286,7 @@
         </p:spPr>
         <p:txBody>
           <a:bodyPr/>
-          <a:lstStyle/>
-          <a:p>
-            <a:endParaRPr/>
-          </a:p>
+          <a:p/>
         </p:txBody>
       </p:sp>
       <p:sp>
@@ -4247,7 +5310,7 @@
           <a:bodyPr wrap="square" lIns="0" tIns="0" rIns="0" bIns="0" rtlCol="0" anchor="ctr"/>
           <a:lstStyle/>
           <a:p>
-            <a:pPr marL="0" indent="0">
+            <a:pPr indent="0" marL="0">
               <a:buNone/>
             </a:pPr>
             <a:r>
@@ -4286,10 +5349,7 @@
         </p:spPr>
         <p:txBody>
           <a:bodyPr/>
-          <a:lstStyle/>
-          <a:p>
-            <a:endParaRPr/>
-          </a:p>
+          <a:p/>
         </p:txBody>
       </p:sp>
       <p:sp>
@@ -4313,7 +5373,7 @@
           <a:bodyPr wrap="square" lIns="0" tIns="0" rIns="0" bIns="0" rtlCol="0" anchor="ctr"/>
           <a:lstStyle/>
           <a:p>
-            <a:pPr marL="0" indent="0">
+            <a:pPr indent="0" marL="0">
               <a:buNone/>
             </a:pPr>
             <a:r>
@@ -4352,7 +5412,7 @@
           <a:bodyPr wrap="square" lIns="0" tIns="0" rIns="0" bIns="0" rtlCol="0" anchor="ctr"/>
           <a:lstStyle/>
           <a:p>
-            <a:pPr marL="0" indent="0" algn="r">
+            <a:pPr algn="r" indent="0" marL="0">
               <a:buNone/>
             </a:pPr>
             <a:r>
@@ -4386,7 +5446,6 @@
         <a:solidFill>
           <a:srgbClr val="F4F0E8"/>
         </a:solidFill>
-        <a:effectLst/>
       </p:bgPr>
     </p:bg>
     <p:spTree>
@@ -4424,10 +5483,7 @@
         </p:spPr>
         <p:txBody>
           <a:bodyPr/>
-          <a:lstStyle/>
-          <a:p>
-            <a:endParaRPr/>
-          </a:p>
+          <a:p/>
         </p:txBody>
       </p:sp>
       <p:sp>
@@ -4451,7 +5507,7 @@
           <a:bodyPr wrap="square" lIns="0" tIns="0" rIns="0" bIns="0" rtlCol="0" anchor="ctr"/>
           <a:lstStyle/>
           <a:p>
-            <a:pPr marL="0" indent="0" algn="ctr">
+            <a:pPr algn="ctr" indent="0" marL="0">
               <a:buNone/>
             </a:pPr>
             <a:r>
@@ -4490,11 +5546,11 @@
           <a:bodyPr wrap="square" lIns="0" tIns="0" rIns="0" bIns="0" rtlCol="0" anchor="ctr"/>
           <a:lstStyle/>
           <a:p>
-            <a:pPr marL="0" indent="0">
+            <a:pPr indent="0" marL="0">
               <a:buNone/>
             </a:pPr>
             <a:r>
-              <a:rPr lang="en-US" sz="1100" b="1" kern="0" spc="200" dirty="0">
+              <a:rPr lang="en-US" sz="1100" b="1" spc="200" kern="0" dirty="0">
                 <a:solidFill>
                   <a:srgbClr val="0E8A82"/>
                 </a:solidFill>
@@ -4529,7 +5585,7 @@
           <a:bodyPr wrap="square" lIns="0" tIns="0" rIns="0" bIns="0" rtlCol="0" anchor="ctr"/>
           <a:lstStyle/>
           <a:p>
-            <a:pPr marL="0" indent="0">
+            <a:pPr indent="0" marL="0">
               <a:buNone/>
             </a:pPr>
             <a:r>
@@ -4571,7 +5627,7 @@
             <a:prstDash val="solid"/>
           </a:ln>
           <a:effectLst>
-            <a:outerShdw blurRad="88900" dist="38100" dir="8100000" algn="bl" rotWithShape="0">
+            <a:outerShdw sx="100000" sy="100000" kx="0" ky="0" algn="bl" rotWithShape="0" blurRad="88900" dist="38100" dir="8100000">
               <a:srgbClr val="0E2A3B">
                 <a:alpha val="16000"/>
               </a:srgbClr>
@@ -4580,10 +5636,7 @@
         </p:spPr>
         <p:txBody>
           <a:bodyPr/>
-          <a:lstStyle/>
-          <a:p>
-            <a:endParaRPr/>
-          </a:p>
+          <a:p/>
         </p:txBody>
       </p:sp>
       <p:sp>
@@ -4607,10 +5660,7 @@
         </p:spPr>
         <p:txBody>
           <a:bodyPr/>
-          <a:lstStyle/>
-          <a:p>
-            <a:endParaRPr/>
-          </a:p>
+          <a:p/>
         </p:txBody>
       </p:sp>
       <p:sp>
@@ -4634,7 +5684,7 @@
           <a:bodyPr wrap="square" lIns="0" tIns="0" rIns="0" bIns="0" rtlCol="0" anchor="t"/>
           <a:lstStyle/>
           <a:p>
-            <a:pPr marL="0" indent="0">
+            <a:pPr indent="0" marL="0">
               <a:buNone/>
             </a:pPr>
             <a:r>
@@ -4770,7 +5820,7 @@
             <a:prstDash val="solid"/>
           </a:ln>
           <a:effectLst>
-            <a:outerShdw blurRad="88900" dist="38100" dir="8100000" algn="bl" rotWithShape="0">
+            <a:outerShdw sx="100000" sy="100000" kx="0" ky="0" algn="bl" rotWithShape="0" blurRad="88900" dist="38100" dir="8100000">
               <a:srgbClr val="0E2A3B">
                 <a:alpha val="16000"/>
               </a:srgbClr>
@@ -4779,10 +5829,7 @@
         </p:spPr>
         <p:txBody>
           <a:bodyPr/>
-          <a:lstStyle/>
-          <a:p>
-            <a:endParaRPr/>
-          </a:p>
+          <a:p/>
         </p:txBody>
       </p:sp>
       <p:sp>
@@ -4806,10 +5853,7 @@
         </p:spPr>
         <p:txBody>
           <a:bodyPr/>
-          <a:lstStyle/>
-          <a:p>
-            <a:endParaRPr/>
-          </a:p>
+          <a:p/>
         </p:txBody>
       </p:sp>
       <p:sp>
@@ -4833,7 +5877,7 @@
           <a:bodyPr wrap="square" lIns="0" tIns="0" rIns="0" bIns="0" rtlCol="0" anchor="t"/>
           <a:lstStyle/>
           <a:p>
-            <a:pPr marL="0" indent="0">
+            <a:pPr indent="0" marL="0">
               <a:buNone/>
             </a:pPr>
             <a:r>
@@ -4969,7 +6013,7 @@
             <a:prstDash val="solid"/>
           </a:ln>
           <a:effectLst>
-            <a:outerShdw blurRad="88900" dist="38100" dir="8100000" algn="bl" rotWithShape="0">
+            <a:outerShdw sx="100000" sy="100000" kx="0" ky="0" algn="bl" rotWithShape="0" blurRad="88900" dist="38100" dir="8100000">
               <a:srgbClr val="0E2A3B">
                 <a:alpha val="16000"/>
               </a:srgbClr>
@@ -4978,10 +6022,7 @@
         </p:spPr>
         <p:txBody>
           <a:bodyPr/>
-          <a:lstStyle/>
-          <a:p>
-            <a:endParaRPr/>
-          </a:p>
+          <a:p/>
         </p:txBody>
       </p:sp>
       <p:sp>
@@ -5005,10 +6046,7 @@
         </p:spPr>
         <p:txBody>
           <a:bodyPr/>
-          <a:lstStyle/>
-          <a:p>
-            <a:endParaRPr/>
-          </a:p>
+          <a:p/>
         </p:txBody>
       </p:sp>
       <p:sp>
@@ -5032,7 +6070,7 @@
           <a:bodyPr wrap="square" lIns="0" tIns="0" rIns="0" bIns="0" rtlCol="0" anchor="t"/>
           <a:lstStyle/>
           <a:p>
-            <a:pPr marL="0" indent="0">
+            <a:pPr indent="0" marL="0">
               <a:buNone/>
             </a:pPr>
             <a:r>
@@ -5170,10 +6208,7 @@
         </p:spPr>
         <p:txBody>
           <a:bodyPr/>
-          <a:lstStyle/>
-          <a:p>
-            <a:endParaRPr/>
-          </a:p>
+          <a:p/>
         </p:txBody>
       </p:sp>
       <p:sp>
@@ -5197,7 +6232,7 @@
           <a:bodyPr wrap="square" lIns="0" tIns="0" rIns="0" bIns="0" rtlCol="0" anchor="ctr"/>
           <a:lstStyle/>
           <a:p>
-            <a:pPr marL="0" indent="0">
+            <a:pPr indent="0" marL="0">
               <a:lnSpc>
                 <a:spcPct val="103000"/>
               </a:lnSpc>
@@ -5214,6 +6249,12 @@
               </a:rPr>
               <a:t>Pourquoi maintenant : </a:t>
             </a:r>
+            <a:pPr indent="0" marL="0">
+              <a:lnSpc>
+                <a:spcPct val="103000"/>
+              </a:lnSpc>
+              <a:buNone/>
+            </a:pPr>
             <a:r>
               <a:rPr lang="en-US" sz="1150" dirty="0">
                 <a:solidFill>
@@ -5250,10 +6291,7 @@
         </p:spPr>
         <p:txBody>
           <a:bodyPr/>
-          <a:lstStyle/>
-          <a:p>
-            <a:endParaRPr/>
-          </a:p>
+          <a:p/>
         </p:txBody>
       </p:sp>
       <p:sp>
@@ -5277,7 +6315,7 @@
           <a:bodyPr wrap="square" lIns="0" tIns="0" rIns="0" bIns="0" rtlCol="0" anchor="ctr"/>
           <a:lstStyle/>
           <a:p>
-            <a:pPr marL="0" indent="0">
+            <a:pPr indent="0" marL="0">
               <a:buNone/>
             </a:pPr>
             <a:r>
@@ -5316,7 +6354,7 @@
           <a:bodyPr wrap="square" lIns="0" tIns="0" rIns="0" bIns="0" rtlCol="0" anchor="ctr"/>
           <a:lstStyle/>
           <a:p>
-            <a:pPr marL="0" indent="0" algn="r">
+            <a:pPr algn="r" indent="0" marL="0">
               <a:buNone/>
             </a:pPr>
             <a:r>
@@ -5350,7 +6388,6 @@
         <a:solidFill>
           <a:srgbClr val="F4F0E8"/>
         </a:solidFill>
-        <a:effectLst/>
       </p:bgPr>
     </p:bg>
     <p:spTree>
@@ -5388,10 +6425,7 @@
         </p:spPr>
         <p:txBody>
           <a:bodyPr/>
-          <a:lstStyle/>
-          <a:p>
-            <a:endParaRPr/>
-          </a:p>
+          <a:p/>
         </p:txBody>
       </p:sp>
       <p:sp>
@@ -5415,7 +6449,7 @@
           <a:bodyPr wrap="square" lIns="0" tIns="0" rIns="0" bIns="0" rtlCol="0" anchor="ctr"/>
           <a:lstStyle/>
           <a:p>
-            <a:pPr marL="0" indent="0" algn="ctr">
+            <a:pPr algn="ctr" indent="0" marL="0">
               <a:buNone/>
             </a:pPr>
             <a:r>
@@ -5454,11 +6488,11 @@
           <a:bodyPr wrap="square" lIns="0" tIns="0" rIns="0" bIns="0" rtlCol="0" anchor="ctr"/>
           <a:lstStyle/>
           <a:p>
-            <a:pPr marL="0" indent="0">
+            <a:pPr indent="0" marL="0">
               <a:buNone/>
             </a:pPr>
             <a:r>
-              <a:rPr lang="en-US" sz="1100" b="1" kern="0" spc="200" dirty="0">
+              <a:rPr lang="en-US" sz="1100" b="1" spc="200" kern="0" dirty="0">
                 <a:solidFill>
                   <a:srgbClr val="0E8A82"/>
                 </a:solidFill>
@@ -5493,7 +6527,7 @@
           <a:bodyPr wrap="square" lIns="0" tIns="0" rIns="0" bIns="0" rtlCol="0" anchor="ctr"/>
           <a:lstStyle/>
           <a:p>
-            <a:pPr marL="0" indent="0">
+            <a:pPr indent="0" marL="0">
               <a:buNone/>
             </a:pPr>
             <a:r>
@@ -5535,7 +6569,7 @@
             <a:prstDash val="solid"/>
           </a:ln>
           <a:effectLst>
-            <a:outerShdw blurRad="88900" dist="38100" dir="8100000" algn="bl" rotWithShape="0">
+            <a:outerShdw sx="100000" sy="100000" kx="0" ky="0" algn="bl" rotWithShape="0" blurRad="88900" dist="38100" dir="8100000">
               <a:srgbClr val="0E2A3B">
                 <a:alpha val="16000"/>
               </a:srgbClr>
@@ -5544,10 +6578,7 @@
         </p:spPr>
         <p:txBody>
           <a:bodyPr/>
-          <a:lstStyle/>
-          <a:p>
-            <a:endParaRPr/>
-          </a:p>
+          <a:p/>
         </p:txBody>
       </p:sp>
       <p:sp>
@@ -5571,10 +6602,7 @@
         </p:spPr>
         <p:txBody>
           <a:bodyPr/>
-          <a:lstStyle/>
-          <a:p>
-            <a:endParaRPr/>
-          </a:p>
+          <a:p/>
         </p:txBody>
       </p:sp>
       <p:sp>
@@ -5598,7 +6626,7 @@
           <a:bodyPr wrap="square" lIns="0" tIns="0" rIns="0" bIns="0" rtlCol="0" anchor="t"/>
           <a:lstStyle/>
           <a:p>
-            <a:pPr marL="0" indent="0">
+            <a:pPr indent="0" marL="0">
               <a:buNone/>
             </a:pPr>
             <a:r>
@@ -5806,7 +6834,7 @@
             <a:prstDash val="solid"/>
           </a:ln>
           <a:effectLst>
-            <a:outerShdw blurRad="88900" dist="38100" dir="8100000" algn="bl" rotWithShape="0">
+            <a:outerShdw sx="100000" sy="100000" kx="0" ky="0" algn="bl" rotWithShape="0" blurRad="88900" dist="38100" dir="8100000">
               <a:srgbClr val="0E2A3B">
                 <a:alpha val="16000"/>
               </a:srgbClr>
@@ -5815,10 +6843,7 @@
         </p:spPr>
         <p:txBody>
           <a:bodyPr/>
-          <a:lstStyle/>
-          <a:p>
-            <a:endParaRPr/>
-          </a:p>
+          <a:p/>
         </p:txBody>
       </p:sp>
       <p:sp>
@@ -5842,10 +6867,7 @@
         </p:spPr>
         <p:txBody>
           <a:bodyPr/>
-          <a:lstStyle/>
-          <a:p>
-            <a:endParaRPr/>
-          </a:p>
+          <a:p/>
         </p:txBody>
       </p:sp>
       <p:sp>
@@ -5869,7 +6891,7 @@
           <a:bodyPr wrap="square" lIns="0" tIns="0" rIns="0" bIns="0" rtlCol="0" anchor="t"/>
           <a:lstStyle/>
           <a:p>
-            <a:pPr marL="0" indent="0">
+            <a:pPr indent="0" marL="0">
               <a:buNone/>
             </a:pPr>
             <a:r>
@@ -6074,10 +7096,7 @@
         </p:spPr>
         <p:txBody>
           <a:bodyPr/>
-          <a:lstStyle/>
-          <a:p>
-            <a:endParaRPr/>
-          </a:p>
+          <a:p/>
         </p:txBody>
       </p:sp>
       <p:sp>
@@ -6101,7 +7120,7 @@
           <a:bodyPr wrap="square" lIns="0" tIns="0" rIns="0" bIns="0" rtlCol="0" anchor="ctr"/>
           <a:lstStyle/>
           <a:p>
-            <a:pPr marL="0" indent="0">
+            <a:pPr indent="0" marL="0">
               <a:lnSpc>
                 <a:spcPct val="103000"/>
               </a:lnSpc>
@@ -6143,10 +7162,7 @@
         </p:spPr>
         <p:txBody>
           <a:bodyPr/>
-          <a:lstStyle/>
-          <a:p>
-            <a:endParaRPr/>
-          </a:p>
+          <a:p/>
         </p:txBody>
       </p:sp>
       <p:sp>
@@ -6170,7 +7186,7 @@
           <a:bodyPr wrap="square" lIns="0" tIns="0" rIns="0" bIns="0" rtlCol="0" anchor="ctr"/>
           <a:lstStyle/>
           <a:p>
-            <a:pPr marL="0" indent="0">
+            <a:pPr indent="0" marL="0">
               <a:buNone/>
             </a:pPr>
             <a:r>
@@ -6209,7 +7225,7 @@
           <a:bodyPr wrap="square" lIns="0" tIns="0" rIns="0" bIns="0" rtlCol="0" anchor="ctr"/>
           <a:lstStyle/>
           <a:p>
-            <a:pPr marL="0" indent="0" algn="r">
+            <a:pPr algn="r" indent="0" marL="0">
               <a:buNone/>
             </a:pPr>
             <a:r>
@@ -6243,7 +7259,6 @@
         <a:solidFill>
           <a:srgbClr val="F4F0E8"/>
         </a:solidFill>
-        <a:effectLst/>
       </p:bgPr>
     </p:bg>
     <p:spTree>
@@ -6281,10 +7296,7 @@
         </p:spPr>
         <p:txBody>
           <a:bodyPr/>
-          <a:lstStyle/>
-          <a:p>
-            <a:endParaRPr/>
-          </a:p>
+          <a:p/>
         </p:txBody>
       </p:sp>
       <p:sp>
@@ -6308,7 +7320,7 @@
           <a:bodyPr wrap="square" lIns="0" tIns="0" rIns="0" bIns="0" rtlCol="0" anchor="ctr"/>
           <a:lstStyle/>
           <a:p>
-            <a:pPr marL="0" indent="0" algn="ctr">
+            <a:pPr algn="ctr" indent="0" marL="0">
               <a:buNone/>
             </a:pPr>
             <a:r>
@@ -6347,11 +7359,11 @@
           <a:bodyPr wrap="square" lIns="0" tIns="0" rIns="0" bIns="0" rtlCol="0" anchor="ctr"/>
           <a:lstStyle/>
           <a:p>
-            <a:pPr marL="0" indent="0">
+            <a:pPr indent="0" marL="0">
               <a:buNone/>
             </a:pPr>
             <a:r>
-              <a:rPr lang="en-US" sz="1100" b="1" kern="0" spc="200" dirty="0">
+              <a:rPr lang="en-US" sz="1100" b="1" spc="200" kern="0" dirty="0">
                 <a:solidFill>
                   <a:srgbClr val="0E8A82"/>
                 </a:solidFill>
@@ -6386,7 +7398,7 @@
           <a:bodyPr wrap="square" lIns="0" tIns="0" rIns="0" bIns="0" rtlCol="0" anchor="ctr"/>
           <a:lstStyle/>
           <a:p>
-            <a:pPr marL="0" indent="0">
+            <a:pPr indent="0" marL="0">
               <a:buNone/>
             </a:pPr>
             <a:r>
@@ -6423,7 +7435,7 @@
           </a:solidFill>
           <a:ln/>
           <a:effectLst>
-            <a:outerShdw blurRad="88900" dist="38100" dir="8100000" algn="bl" rotWithShape="0">
+            <a:outerShdw sx="100000" sy="100000" kx="0" ky="0" algn="bl" rotWithShape="0" blurRad="88900" dist="38100" dir="8100000">
               <a:srgbClr val="0E2A3B">
                 <a:alpha val="16000"/>
               </a:srgbClr>
@@ -6432,10 +7444,7 @@
         </p:spPr>
         <p:txBody>
           <a:bodyPr/>
-          <a:lstStyle/>
-          <a:p>
-            <a:endParaRPr/>
-          </a:p>
+          <a:p/>
         </p:txBody>
       </p:sp>
       <p:sp>
@@ -6459,10 +7468,7 @@
         </p:spPr>
         <p:txBody>
           <a:bodyPr/>
-          <a:lstStyle/>
-          <a:p>
-            <a:endParaRPr/>
-          </a:p>
+          <a:p/>
         </p:txBody>
       </p:sp>
       <p:sp>
@@ -6486,7 +7492,7 @@
           <a:bodyPr wrap="square" lIns="0" tIns="0" rIns="0" bIns="0" rtlCol="0" anchor="ctr"/>
           <a:lstStyle/>
           <a:p>
-            <a:pPr marL="0" indent="0" algn="ctr">
+            <a:pPr algn="ctr" indent="0" marL="0">
               <a:buNone/>
             </a:pPr>
             <a:r>
@@ -6525,7 +7531,7 @@
           <a:bodyPr wrap="square" lIns="0" tIns="0" rIns="0" bIns="0" rtlCol="0" anchor="t"/>
           <a:lstStyle/>
           <a:p>
-            <a:pPr marL="0" indent="0" algn="ctr">
+            <a:pPr algn="ctr" indent="0" marL="0">
               <a:buNone/>
             </a:pPr>
             <a:r>
@@ -6562,7 +7568,7 @@
           </a:solidFill>
           <a:ln/>
           <a:effectLst>
-            <a:outerShdw blurRad="88900" dist="38100" dir="8100000" algn="bl" rotWithShape="0">
+            <a:outerShdw sx="100000" sy="100000" kx="0" ky="0" algn="bl" rotWithShape="0" blurRad="88900" dist="38100" dir="8100000">
               <a:srgbClr val="0E2A3B">
                 <a:alpha val="16000"/>
               </a:srgbClr>
@@ -6571,10 +7577,7 @@
         </p:spPr>
         <p:txBody>
           <a:bodyPr/>
-          <a:lstStyle/>
-          <a:p>
-            <a:endParaRPr/>
-          </a:p>
+          <a:p/>
         </p:txBody>
       </p:sp>
       <p:sp>
@@ -6598,10 +7601,7 @@
         </p:spPr>
         <p:txBody>
           <a:bodyPr/>
-          <a:lstStyle/>
-          <a:p>
-            <a:endParaRPr/>
-          </a:p>
+          <a:p/>
         </p:txBody>
       </p:sp>
       <p:sp>
@@ -6625,7 +7625,7 @@
           <a:bodyPr wrap="square" lIns="0" tIns="0" rIns="0" bIns="0" rtlCol="0" anchor="ctr"/>
           <a:lstStyle/>
           <a:p>
-            <a:pPr marL="0" indent="0" algn="ctr">
+            <a:pPr algn="ctr" indent="0" marL="0">
               <a:buNone/>
             </a:pPr>
             <a:r>
@@ -6664,7 +7664,7 @@
           <a:bodyPr wrap="square" lIns="0" tIns="0" rIns="0" bIns="0" rtlCol="0" anchor="t"/>
           <a:lstStyle/>
           <a:p>
-            <a:pPr marL="0" indent="0" algn="ctr">
+            <a:pPr algn="ctr" indent="0" marL="0">
               <a:buNone/>
             </a:pPr>
             <a:r>
@@ -6701,7 +7701,7 @@
           </a:solidFill>
           <a:ln/>
           <a:effectLst>
-            <a:outerShdw blurRad="88900" dist="38100" dir="8100000" algn="bl" rotWithShape="0">
+            <a:outerShdw sx="100000" sy="100000" kx="0" ky="0" algn="bl" rotWithShape="0" blurRad="88900" dist="38100" dir="8100000">
               <a:srgbClr val="0E2A3B">
                 <a:alpha val="16000"/>
               </a:srgbClr>
@@ -6710,10 +7710,7 @@
         </p:spPr>
         <p:txBody>
           <a:bodyPr/>
-          <a:lstStyle/>
-          <a:p>
-            <a:endParaRPr/>
-          </a:p>
+          <a:p/>
         </p:txBody>
       </p:sp>
       <p:sp>
@@ -6737,10 +7734,7 @@
         </p:spPr>
         <p:txBody>
           <a:bodyPr/>
-          <a:lstStyle/>
-          <a:p>
-            <a:endParaRPr/>
-          </a:p>
+          <a:p/>
         </p:txBody>
       </p:sp>
       <p:sp>
@@ -6764,7 +7758,7 @@
           <a:bodyPr wrap="square" lIns="0" tIns="0" rIns="0" bIns="0" rtlCol="0" anchor="ctr"/>
           <a:lstStyle/>
           <a:p>
-            <a:pPr marL="0" indent="0" algn="ctr">
+            <a:pPr algn="ctr" indent="0" marL="0">
               <a:buNone/>
             </a:pPr>
             <a:r>
@@ -6803,7 +7797,7 @@
           <a:bodyPr wrap="square" lIns="0" tIns="0" rIns="0" bIns="0" rtlCol="0" anchor="t"/>
           <a:lstStyle/>
           <a:p>
-            <a:pPr marL="0" indent="0" algn="ctr">
+            <a:pPr algn="ctr" indent="0" marL="0">
               <a:buNone/>
             </a:pPr>
             <a:r>
@@ -6840,7 +7834,7 @@
           </a:solidFill>
           <a:ln/>
           <a:effectLst>
-            <a:outerShdw blurRad="88900" dist="38100" dir="8100000" algn="bl" rotWithShape="0">
+            <a:outerShdw sx="100000" sy="100000" kx="0" ky="0" algn="bl" rotWithShape="0" blurRad="88900" dist="38100" dir="8100000">
               <a:srgbClr val="0E2A3B">
                 <a:alpha val="16000"/>
               </a:srgbClr>
@@ -6849,10 +7843,7 @@
         </p:spPr>
         <p:txBody>
           <a:bodyPr/>
-          <a:lstStyle/>
-          <a:p>
-            <a:endParaRPr/>
-          </a:p>
+          <a:p/>
         </p:txBody>
       </p:sp>
       <p:sp>
@@ -6876,10 +7867,7 @@
         </p:spPr>
         <p:txBody>
           <a:bodyPr/>
-          <a:lstStyle/>
-          <a:p>
-            <a:endParaRPr/>
-          </a:p>
+          <a:p/>
         </p:txBody>
       </p:sp>
       <p:sp>
@@ -6903,7 +7891,7 @@
           <a:bodyPr wrap="square" lIns="0" tIns="0" rIns="0" bIns="0" rtlCol="0" anchor="ctr"/>
           <a:lstStyle/>
           <a:p>
-            <a:pPr marL="0" indent="0" algn="ctr">
+            <a:pPr algn="ctr" indent="0" marL="0">
               <a:buNone/>
             </a:pPr>
             <a:r>
@@ -6942,7 +7930,7 @@
           <a:bodyPr wrap="square" lIns="0" tIns="0" rIns="0" bIns="0" rtlCol="0" anchor="t"/>
           <a:lstStyle/>
           <a:p>
-            <a:pPr marL="0" indent="0" algn="ctr">
+            <a:pPr algn="ctr" indent="0" marL="0">
               <a:buNone/>
             </a:pPr>
             <a:r>
@@ -6984,7 +7972,7 @@
             <a:prstDash val="solid"/>
           </a:ln>
           <a:effectLst>
-            <a:outerShdw blurRad="88900" dist="38100" dir="8100000" algn="bl" rotWithShape="0">
+            <a:outerShdw sx="100000" sy="100000" kx="0" ky="0" algn="bl" rotWithShape="0" blurRad="88900" dist="38100" dir="8100000">
               <a:srgbClr val="0E2A3B">
                 <a:alpha val="16000"/>
               </a:srgbClr>
@@ -6993,10 +7981,7 @@
         </p:spPr>
         <p:txBody>
           <a:bodyPr/>
-          <a:lstStyle/>
-          <a:p>
-            <a:endParaRPr/>
-          </a:p>
+          <a:p/>
         </p:txBody>
       </p:sp>
       <p:sp>
@@ -7020,10 +8005,7 @@
         </p:spPr>
         <p:txBody>
           <a:bodyPr/>
-          <a:lstStyle/>
-          <a:p>
-            <a:endParaRPr/>
-          </a:p>
+          <a:p/>
         </p:txBody>
       </p:sp>
       <p:sp>
@@ -7047,7 +8029,7 @@
           <a:bodyPr wrap="square" lIns="0" tIns="0" rIns="0" bIns="0" rtlCol="0" anchor="t"/>
           <a:lstStyle/>
           <a:p>
-            <a:pPr marL="0" indent="0">
+            <a:pPr indent="0" marL="0">
               <a:buNone/>
             </a:pPr>
             <a:r>
@@ -7207,7 +8189,7 @@
             <a:prstDash val="solid"/>
           </a:ln>
           <a:effectLst>
-            <a:outerShdw blurRad="88900" dist="38100" dir="8100000" algn="bl" rotWithShape="0">
+            <a:outerShdw sx="100000" sy="100000" kx="0" ky="0" algn="bl" rotWithShape="0" blurRad="88900" dist="38100" dir="8100000">
               <a:srgbClr val="0E2A3B">
                 <a:alpha val="16000"/>
               </a:srgbClr>
@@ -7216,10 +8198,7 @@
         </p:spPr>
         <p:txBody>
           <a:bodyPr/>
-          <a:lstStyle/>
-          <a:p>
-            <a:endParaRPr/>
-          </a:p>
+          <a:p/>
         </p:txBody>
       </p:sp>
       <p:sp>
@@ -7243,10 +8222,7 @@
         </p:spPr>
         <p:txBody>
           <a:bodyPr/>
-          <a:lstStyle/>
-          <a:p>
-            <a:endParaRPr/>
-          </a:p>
+          <a:p/>
         </p:txBody>
       </p:sp>
       <p:sp>
@@ -7270,7 +8246,7 @@
           <a:bodyPr wrap="square" lIns="0" tIns="0" rIns="0" bIns="0" rtlCol="0" anchor="ctr"/>
           <a:lstStyle/>
           <a:p>
-            <a:pPr marL="0" indent="0">
+            <a:pPr indent="0" marL="0">
               <a:buNone/>
             </a:pPr>
             <a:r>
@@ -7290,7 +8266,7 @@
       </p:sp>
       <p:graphicFrame>
         <p:nvGraphicFramePr>
-          <p:cNvPr id="29" name="Chart 0"/>
+          <p:cNvPr id="29" name="Chart 0" descr=""/>
           <p:cNvGraphicFramePr/>
           <p:nvPr/>
         </p:nvGraphicFramePr>
@@ -7298,9 +8274,9 @@
           <a:off x="6263640" y="3611880"/>
           <a:ext cx="5349240" cy="1737360"/>
         </p:xfrm>
-        <a:graphic>
+        <a:graphic xmlns:a="http://schemas.openxmlformats.org/drawingml/2006/main">
           <a:graphicData uri="http://schemas.openxmlformats.org/drawingml/2006/chart">
-            <c:chart xmlns:c="http://schemas.openxmlformats.org/drawingml/2006/chart" xmlns:r="http://schemas.openxmlformats.org/officeDocument/2006/relationships" r:id="rId3"/>
+            <c:chart xmlns:c="http://schemas.openxmlformats.org/drawingml/2006/chart" r:id="rId1"/>
           </a:graphicData>
         </a:graphic>
       </p:graphicFrame>
@@ -7327,7 +8303,7 @@
           <a:bodyPr wrap="square" lIns="76200" tIns="76200" rIns="76200" bIns="76200" rtlCol="0" anchor="ctr"/>
           <a:lstStyle/>
           <a:p>
-            <a:pPr marL="0" indent="0" algn="l">
+            <a:pPr algn="l" indent="0" marL="0">
               <a:lnSpc>
                 <a:spcPct val="100000"/>
               </a:lnSpc>
@@ -7369,10 +8345,7 @@
         </p:spPr>
         <p:txBody>
           <a:bodyPr/>
-          <a:lstStyle/>
-          <a:p>
-            <a:endParaRPr/>
-          </a:p>
+          <a:p/>
         </p:txBody>
       </p:sp>
       <p:sp>
@@ -7396,7 +8369,7 @@
           <a:bodyPr wrap="square" lIns="0" tIns="0" rIns="0" bIns="0" rtlCol="0" anchor="ctr"/>
           <a:lstStyle/>
           <a:p>
-            <a:pPr marL="0" indent="0">
+            <a:pPr indent="0" marL="0">
               <a:buNone/>
             </a:pPr>
             <a:r>
@@ -7435,7 +8408,7 @@
           <a:bodyPr wrap="square" lIns="0" tIns="0" rIns="0" bIns="0" rtlCol="0" anchor="ctr"/>
           <a:lstStyle/>
           <a:p>
-            <a:pPr marL="0" indent="0" algn="r">
+            <a:pPr algn="r" indent="0" marL="0">
               <a:buNone/>
             </a:pPr>
             <a:r>
@@ -7469,7 +8442,6 @@
         <a:solidFill>
           <a:srgbClr val="F4F0E8"/>
         </a:solidFill>
-        <a:effectLst/>
       </p:bgPr>
     </p:bg>
     <p:spTree>
@@ -7507,10 +8479,7 @@
         </p:spPr>
         <p:txBody>
           <a:bodyPr/>
-          <a:lstStyle/>
-          <a:p>
-            <a:endParaRPr/>
-          </a:p>
+          <a:p/>
         </p:txBody>
       </p:sp>
       <p:sp>
@@ -7534,7 +8503,7 @@
           <a:bodyPr wrap="square" lIns="0" tIns="0" rIns="0" bIns="0" rtlCol="0" anchor="ctr"/>
           <a:lstStyle/>
           <a:p>
-            <a:pPr marL="0" indent="0" algn="ctr">
+            <a:pPr algn="ctr" indent="0" marL="0">
               <a:buNone/>
             </a:pPr>
             <a:r>
@@ -7573,11 +8542,11 @@
           <a:bodyPr wrap="square" lIns="0" tIns="0" rIns="0" bIns="0" rtlCol="0" anchor="ctr"/>
           <a:lstStyle/>
           <a:p>
-            <a:pPr marL="0" indent="0">
+            <a:pPr indent="0" marL="0">
               <a:buNone/>
             </a:pPr>
             <a:r>
-              <a:rPr lang="en-US" sz="1100" b="1" kern="0" spc="200" dirty="0">
+              <a:rPr lang="en-US" sz="1100" b="1" spc="200" kern="0" dirty="0">
                 <a:solidFill>
                   <a:srgbClr val="0E8A82"/>
                 </a:solidFill>
@@ -7612,7 +8581,7 @@
           <a:bodyPr wrap="square" lIns="0" tIns="0" rIns="0" bIns="0" rtlCol="0" anchor="ctr"/>
           <a:lstStyle/>
           <a:p>
-            <a:pPr marL="0" indent="0">
+            <a:pPr indent="0" marL="0">
               <a:buNone/>
             </a:pPr>
             <a:r>
@@ -7654,7 +8623,7 @@
             <a:prstDash val="solid"/>
           </a:ln>
           <a:effectLst>
-            <a:outerShdw blurRad="88900" dist="38100" dir="8100000" algn="bl" rotWithShape="0">
+            <a:outerShdw sx="100000" sy="100000" kx="0" ky="0" algn="bl" rotWithShape="0" blurRad="88900" dist="38100" dir="8100000">
               <a:srgbClr val="0E2A3B">
                 <a:alpha val="16000"/>
               </a:srgbClr>
@@ -7663,10 +8632,7 @@
         </p:spPr>
         <p:txBody>
           <a:bodyPr/>
-          <a:lstStyle/>
-          <a:p>
-            <a:endParaRPr/>
-          </a:p>
+          <a:p/>
         </p:txBody>
       </p:sp>
       <p:sp>
@@ -7690,10 +8656,7 @@
         </p:spPr>
         <p:txBody>
           <a:bodyPr/>
-          <a:lstStyle/>
-          <a:p>
-            <a:endParaRPr/>
-          </a:p>
+          <a:p/>
         </p:txBody>
       </p:sp>
       <p:sp>
@@ -7717,7 +8680,7 @@
           <a:bodyPr wrap="square" lIns="0" tIns="0" rIns="0" bIns="0" rtlCol="0" anchor="t"/>
           <a:lstStyle/>
           <a:p>
-            <a:pPr marL="0" indent="0">
+            <a:pPr indent="0" marL="0">
               <a:buNone/>
             </a:pPr>
             <a:r>
@@ -7853,7 +8816,7 @@
             <a:prstDash val="solid"/>
           </a:ln>
           <a:effectLst>
-            <a:outerShdw blurRad="88900" dist="38100" dir="8100000" algn="bl" rotWithShape="0">
+            <a:outerShdw sx="100000" sy="100000" kx="0" ky="0" algn="bl" rotWithShape="0" blurRad="88900" dist="38100" dir="8100000">
               <a:srgbClr val="0E2A3B">
                 <a:alpha val="16000"/>
               </a:srgbClr>
@@ -7862,10 +8825,7 @@
         </p:spPr>
         <p:txBody>
           <a:bodyPr/>
-          <a:lstStyle/>
-          <a:p>
-            <a:endParaRPr/>
-          </a:p>
+          <a:p/>
         </p:txBody>
       </p:sp>
       <p:sp>
@@ -7889,10 +8849,7 @@
         </p:spPr>
         <p:txBody>
           <a:bodyPr/>
-          <a:lstStyle/>
-          <a:p>
-            <a:endParaRPr/>
-          </a:p>
+          <a:p/>
         </p:txBody>
       </p:sp>
       <p:sp>
@@ -7916,7 +8873,7 @@
           <a:bodyPr wrap="square" lIns="0" tIns="0" rIns="0" bIns="0" rtlCol="0" anchor="t"/>
           <a:lstStyle/>
           <a:p>
-            <a:pPr marL="0" indent="0">
+            <a:pPr indent="0" marL="0">
               <a:buNone/>
             </a:pPr>
             <a:r>
@@ -8052,7 +9009,7 @@
             <a:prstDash val="solid"/>
           </a:ln>
           <a:effectLst>
-            <a:outerShdw blurRad="88900" dist="38100" dir="8100000" algn="bl" rotWithShape="0">
+            <a:outerShdw sx="100000" sy="100000" kx="0" ky="0" algn="bl" rotWithShape="0" blurRad="88900" dist="38100" dir="8100000">
               <a:srgbClr val="0E2A3B">
                 <a:alpha val="16000"/>
               </a:srgbClr>
@@ -8061,10 +9018,7 @@
         </p:spPr>
         <p:txBody>
           <a:bodyPr/>
-          <a:lstStyle/>
-          <a:p>
-            <a:endParaRPr/>
-          </a:p>
+          <a:p/>
         </p:txBody>
       </p:sp>
       <p:sp>
@@ -8088,10 +9042,7 @@
         </p:spPr>
         <p:txBody>
           <a:bodyPr/>
-          <a:lstStyle/>
-          <a:p>
-            <a:endParaRPr/>
-          </a:p>
+          <a:p/>
         </p:txBody>
       </p:sp>
       <p:sp>
@@ -8115,7 +9066,7 @@
           <a:bodyPr wrap="square" lIns="0" tIns="0" rIns="0" bIns="0" rtlCol="0" anchor="t"/>
           <a:lstStyle/>
           <a:p>
-            <a:pPr marL="0" indent="0">
+            <a:pPr indent="0" marL="0">
               <a:buNone/>
             </a:pPr>
             <a:r>
@@ -8251,7 +9202,7 @@
             <a:prstDash val="solid"/>
           </a:ln>
           <a:effectLst>
-            <a:outerShdw blurRad="88900" dist="38100" dir="8100000" algn="bl" rotWithShape="0">
+            <a:outerShdw sx="100000" sy="100000" kx="0" ky="0" algn="bl" rotWithShape="0" blurRad="88900" dist="38100" dir="8100000">
               <a:srgbClr val="0E2A3B">
                 <a:alpha val="16000"/>
               </a:srgbClr>
@@ -8260,10 +9211,7 @@
         </p:spPr>
         <p:txBody>
           <a:bodyPr/>
-          <a:lstStyle/>
-          <a:p>
-            <a:endParaRPr/>
-          </a:p>
+          <a:p/>
         </p:txBody>
       </p:sp>
       <p:sp>
@@ -8287,10 +9235,7 @@
         </p:spPr>
         <p:txBody>
           <a:bodyPr/>
-          <a:lstStyle/>
-          <a:p>
-            <a:endParaRPr/>
-          </a:p>
+          <a:p/>
         </p:txBody>
       </p:sp>
       <p:sp>
@@ -8314,7 +9259,7 @@
           <a:bodyPr wrap="square" lIns="0" tIns="0" rIns="0" bIns="0" rtlCol="0" anchor="t"/>
           <a:lstStyle/>
           <a:p>
-            <a:pPr marL="0" indent="0">
+            <a:pPr indent="0" marL="0">
               <a:buNone/>
             </a:pPr>
             <a:r>
@@ -8447,10 +9392,7 @@
         </p:spPr>
         <p:txBody>
           <a:bodyPr/>
-          <a:lstStyle/>
-          <a:p>
-            <a:endParaRPr/>
-          </a:p>
+          <a:p/>
         </p:txBody>
       </p:sp>
       <p:sp>
@@ -8474,7 +9416,7 @@
           <a:bodyPr wrap="square" lIns="0" tIns="0" rIns="0" bIns="0" rtlCol="0" anchor="ctr"/>
           <a:lstStyle/>
           <a:p>
-            <a:pPr marL="0" indent="0">
+            <a:pPr indent="0" marL="0">
               <a:lnSpc>
                 <a:spcPct val="102000"/>
               </a:lnSpc>
@@ -8516,10 +9458,7 @@
         </p:spPr>
         <p:txBody>
           <a:bodyPr/>
-          <a:lstStyle/>
-          <a:p>
-            <a:endParaRPr/>
-          </a:p>
+          <a:p/>
         </p:txBody>
       </p:sp>
       <p:sp>
@@ -8543,7 +9482,7 @@
           <a:bodyPr wrap="square" lIns="0" tIns="0" rIns="0" bIns="0" rtlCol="0" anchor="ctr"/>
           <a:lstStyle/>
           <a:p>
-            <a:pPr marL="0" indent="0">
+            <a:pPr indent="0" marL="0">
               <a:buNone/>
             </a:pPr>
             <a:r>
@@ -8582,7 +9521,7 @@
           <a:bodyPr wrap="square" lIns="0" tIns="0" rIns="0" bIns="0" rtlCol="0" anchor="ctr"/>
           <a:lstStyle/>
           <a:p>
-            <a:pPr marL="0" indent="0" algn="r">
+            <a:pPr algn="r" indent="0" marL="0">
               <a:buNone/>
             </a:pPr>
             <a:r>
@@ -8616,7 +9555,6 @@
         <a:solidFill>
           <a:srgbClr val="F4F0E8"/>
         </a:solidFill>
-        <a:effectLst/>
       </p:bgPr>
     </p:bg>
     <p:spTree>
@@ -8654,10 +9592,7 @@
         </p:spPr>
         <p:txBody>
           <a:bodyPr/>
-          <a:lstStyle/>
-          <a:p>
-            <a:endParaRPr/>
-          </a:p>
+          <a:p/>
         </p:txBody>
       </p:sp>
       <p:sp>
@@ -8681,7 +9616,7 @@
           <a:bodyPr wrap="square" lIns="0" tIns="0" rIns="0" bIns="0" rtlCol="0" anchor="ctr"/>
           <a:lstStyle/>
           <a:p>
-            <a:pPr marL="0" indent="0" algn="ctr">
+            <a:pPr algn="ctr" indent="0" marL="0">
               <a:buNone/>
             </a:pPr>
             <a:r>
@@ -8720,11 +9655,11 @@
           <a:bodyPr wrap="square" lIns="0" tIns="0" rIns="0" bIns="0" rtlCol="0" anchor="ctr"/>
           <a:lstStyle/>
           <a:p>
-            <a:pPr marL="0" indent="0">
+            <a:pPr indent="0" marL="0">
               <a:buNone/>
             </a:pPr>
             <a:r>
-              <a:rPr lang="en-US" sz="1100" b="1" kern="0" spc="200" dirty="0">
+              <a:rPr lang="en-US" sz="1100" b="1" spc="200" kern="0" dirty="0">
                 <a:solidFill>
                   <a:srgbClr val="0E8A82"/>
                 </a:solidFill>
@@ -8759,7 +9694,7 @@
           <a:bodyPr wrap="square" lIns="0" tIns="0" rIns="0" bIns="0" rtlCol="0" anchor="ctr"/>
           <a:lstStyle/>
           <a:p>
-            <a:pPr marL="0" indent="0">
+            <a:pPr indent="0" marL="0">
               <a:buNone/>
             </a:pPr>
             <a:r>
@@ -8771,29 +9706,7 @@
                 <a:ea typeface="Georgia" pitchFamily="34" charset="-122"/>
                 <a:cs typeface="Georgia" pitchFamily="34" charset="-120"/>
               </a:rPr>
-              <a:t>Ce qui est réellement </a:t>
-            </a:r>
-            <a:r>
-              <a:rPr lang="en-US" sz="2700" b="1" dirty="0" err="1">
-                <a:solidFill>
-                  <a:srgbClr val="0E2A3B"/>
-                </a:solidFill>
-                <a:latin typeface="Georgia" pitchFamily="34" charset="0"/>
-                <a:ea typeface="Georgia" pitchFamily="34" charset="-122"/>
-                <a:cs typeface="Georgia" pitchFamily="34" charset="-120"/>
-              </a:rPr>
-              <a:t>mobilisable</a:t>
-            </a:r>
-            <a:r>
-              <a:rPr lang="en-US" sz="2700" b="1">
-                <a:solidFill>
-                  <a:srgbClr val="0E2A3B"/>
-                </a:solidFill>
-                <a:latin typeface="Georgia" pitchFamily="34" charset="0"/>
-                <a:ea typeface="Georgia" pitchFamily="34" charset="-122"/>
-                <a:cs typeface="Georgia" pitchFamily="34" charset="-120"/>
-              </a:rPr>
-              <a:t> </a:t>
+              <a:t>Ce qui est réellement mobilisable — dit franchement</a:t>
             </a:r>
             <a:endParaRPr lang="en-US" sz="2700" dirty="0"/>
           </a:p>
@@ -8825,10 +9738,7 @@
         </p:spPr>
         <p:txBody>
           <a:bodyPr/>
-          <a:lstStyle/>
-          <a:p>
-            <a:endParaRPr/>
-          </a:p>
+          <a:p/>
         </p:txBody>
       </p:sp>
       <p:sp>
@@ -8852,7 +9762,7 @@
           <a:bodyPr wrap="square" lIns="0" tIns="0" rIns="0" bIns="0" rtlCol="0" anchor="ctr"/>
           <a:lstStyle/>
           <a:p>
-            <a:pPr marL="0" indent="0">
+            <a:pPr indent="0" marL="0">
               <a:lnSpc>
                 <a:spcPct val="100000"/>
               </a:lnSpc>
@@ -8869,6 +9779,12 @@
               </a:rPr>
               <a:t>⚠ Vérité : </a:t>
             </a:r>
+            <a:pPr indent="0" marL="0">
+              <a:lnSpc>
+                <a:spcPct val="100000"/>
+              </a:lnSpc>
+              <a:buNone/>
+            </a:pPr>
             <a:r>
               <a:rPr lang="en-US" sz="1030" dirty="0">
                 <a:solidFill>
@@ -8908,7 +9824,7 @@
             <a:prstDash val="solid"/>
           </a:ln>
           <a:effectLst>
-            <a:outerShdw blurRad="88900" dist="38100" dir="8100000" algn="bl" rotWithShape="0">
+            <a:outerShdw sx="100000" sy="100000" kx="0" ky="0" algn="bl" rotWithShape="0" blurRad="88900" dist="38100" dir="8100000">
               <a:srgbClr val="0E2A3B">
                 <a:alpha val="16000"/>
               </a:srgbClr>
@@ -8917,10 +9833,7 @@
         </p:spPr>
         <p:txBody>
           <a:bodyPr/>
-          <a:lstStyle/>
-          <a:p>
-            <a:endParaRPr/>
-          </a:p>
+          <a:p/>
         </p:txBody>
       </p:sp>
       <p:sp>
@@ -8944,10 +9857,7 @@
         </p:spPr>
         <p:txBody>
           <a:bodyPr/>
-          <a:lstStyle/>
-          <a:p>
-            <a:endParaRPr/>
-          </a:p>
+          <a:p/>
         </p:txBody>
       </p:sp>
       <p:sp>
@@ -8971,7 +9881,7 @@
           <a:bodyPr wrap="square" lIns="0" tIns="0" rIns="0" bIns="0" rtlCol="0" anchor="t"/>
           <a:lstStyle/>
           <a:p>
-            <a:pPr marL="0" indent="0">
+            <a:pPr indent="0" marL="0">
               <a:buNone/>
             </a:pPr>
             <a:r>
@@ -9131,7 +10041,7 @@
             <a:prstDash val="solid"/>
           </a:ln>
           <a:effectLst>
-            <a:outerShdw blurRad="88900" dist="38100" dir="8100000" algn="bl" rotWithShape="0">
+            <a:outerShdw sx="100000" sy="100000" kx="0" ky="0" algn="bl" rotWithShape="0" blurRad="88900" dist="38100" dir="8100000">
               <a:srgbClr val="0E2A3B">
                 <a:alpha val="16000"/>
               </a:srgbClr>
@@ -9140,10 +10050,7 @@
         </p:spPr>
         <p:txBody>
           <a:bodyPr/>
-          <a:lstStyle/>
-          <a:p>
-            <a:endParaRPr/>
-          </a:p>
+          <a:p/>
         </p:txBody>
       </p:sp>
       <p:sp>
@@ -9167,10 +10074,7 @@
         </p:spPr>
         <p:txBody>
           <a:bodyPr/>
-          <a:lstStyle/>
-          <a:p>
-            <a:endParaRPr/>
-          </a:p>
+          <a:p/>
         </p:txBody>
       </p:sp>
       <p:sp>
@@ -9194,7 +10098,7 @@
           <a:bodyPr wrap="square" lIns="0" tIns="0" rIns="0" bIns="0" rtlCol="0" anchor="t"/>
           <a:lstStyle/>
           <a:p>
-            <a:pPr marL="0" indent="0">
+            <a:pPr indent="0" marL="0">
               <a:buNone/>
             </a:pPr>
             <a:r>
@@ -9351,10 +10255,7 @@
         </p:spPr>
         <p:txBody>
           <a:bodyPr/>
-          <a:lstStyle/>
-          <a:p>
-            <a:endParaRPr/>
-          </a:p>
+          <a:p/>
         </p:txBody>
       </p:sp>
       <p:sp>
@@ -9378,7 +10279,7 @@
           <a:bodyPr wrap="square" lIns="0" tIns="0" rIns="0" bIns="0" rtlCol="0" anchor="ctr"/>
           <a:lstStyle/>
           <a:p>
-            <a:pPr marL="0" indent="0">
+            <a:pPr indent="0" marL="0">
               <a:lnSpc>
                 <a:spcPct val="100000"/>
               </a:lnSpc>
@@ -9420,7 +10321,7 @@
           <a:bodyPr wrap="square" lIns="0" tIns="0" rIns="0" bIns="0" rtlCol="0" anchor="ctr"/>
           <a:lstStyle/>
           <a:p>
-            <a:pPr marL="0" indent="0">
+            <a:pPr indent="0" marL="0">
               <a:buNone/>
             </a:pPr>
             <a:r>
@@ -9459,10 +10360,7 @@
         </p:spPr>
         <p:txBody>
           <a:bodyPr/>
-          <a:lstStyle/>
-          <a:p>
-            <a:endParaRPr/>
-          </a:p>
+          <a:p/>
         </p:txBody>
       </p:sp>
       <p:sp>
@@ -9486,7 +10384,7 @@
           <a:bodyPr wrap="square" lIns="0" tIns="0" rIns="0" bIns="0" rtlCol="0" anchor="ctr"/>
           <a:lstStyle/>
           <a:p>
-            <a:pPr marL="0" indent="0">
+            <a:pPr indent="0" marL="0">
               <a:buNone/>
             </a:pPr>
             <a:r>
@@ -9525,7 +10423,7 @@
           <a:bodyPr wrap="square" lIns="0" tIns="0" rIns="0" bIns="0" rtlCol="0" anchor="ctr"/>
           <a:lstStyle/>
           <a:p>
-            <a:pPr marL="0" indent="0" algn="r">
+            <a:pPr algn="r" indent="0" marL="0">
               <a:buNone/>
             </a:pPr>
             <a:r>
@@ -9559,7 +10457,6 @@
         <a:solidFill>
           <a:srgbClr val="F4F0E8"/>
         </a:solidFill>
-        <a:effectLst/>
       </p:bgPr>
     </p:bg>
     <p:spTree>
@@ -9597,10 +10494,7 @@
         </p:spPr>
         <p:txBody>
           <a:bodyPr/>
-          <a:lstStyle/>
-          <a:p>
-            <a:endParaRPr/>
-          </a:p>
+          <a:p/>
         </p:txBody>
       </p:sp>
       <p:sp>
@@ -9624,7 +10518,7 @@
           <a:bodyPr wrap="square" lIns="0" tIns="0" rIns="0" bIns="0" rtlCol="0" anchor="ctr"/>
           <a:lstStyle/>
           <a:p>
-            <a:pPr marL="0" indent="0" algn="ctr">
+            <a:pPr algn="ctr" indent="0" marL="0">
               <a:buNone/>
             </a:pPr>
             <a:r>
@@ -9663,11 +10557,11 @@
           <a:bodyPr wrap="square" lIns="0" tIns="0" rIns="0" bIns="0" rtlCol="0" anchor="ctr"/>
           <a:lstStyle/>
           <a:p>
-            <a:pPr marL="0" indent="0">
+            <a:pPr indent="0" marL="0">
               <a:buNone/>
             </a:pPr>
             <a:r>
-              <a:rPr lang="en-US" sz="1100" b="1" kern="0" spc="200" dirty="0">
+              <a:rPr lang="en-US" sz="1100" b="1" spc="200" kern="0" dirty="0">
                 <a:solidFill>
                   <a:srgbClr val="0E8A82"/>
                 </a:solidFill>
@@ -9702,7 +10596,7 @@
           <a:bodyPr wrap="square" lIns="0" tIns="0" rIns="0" bIns="0" rtlCol="0" anchor="ctr"/>
           <a:lstStyle/>
           <a:p>
-            <a:pPr marL="0" indent="0">
+            <a:pPr indent="0" marL="0">
               <a:buNone/>
             </a:pPr>
             <a:r>
@@ -9744,7 +10638,7 @@
             <a:prstDash val="solid"/>
           </a:ln>
           <a:effectLst>
-            <a:outerShdw blurRad="88900" dist="38100" dir="8100000" algn="bl" rotWithShape="0">
+            <a:outerShdw sx="100000" sy="100000" kx="0" ky="0" algn="bl" rotWithShape="0" blurRad="88900" dist="38100" dir="8100000">
               <a:srgbClr val="0E2A3B">
                 <a:alpha val="16000"/>
               </a:srgbClr>
@@ -9753,10 +10647,7 @@
         </p:spPr>
         <p:txBody>
           <a:bodyPr/>
-          <a:lstStyle/>
-          <a:p>
-            <a:endParaRPr/>
-          </a:p>
+          <a:p/>
         </p:txBody>
       </p:sp>
       <p:sp>
@@ -9780,10 +10671,7 @@
         </p:spPr>
         <p:txBody>
           <a:bodyPr/>
-          <a:lstStyle/>
-          <a:p>
-            <a:endParaRPr/>
-          </a:p>
+          <a:p/>
         </p:txBody>
       </p:sp>
       <p:sp>
@@ -9807,7 +10695,7 @@
           <a:bodyPr wrap="square" lIns="0" tIns="0" rIns="0" bIns="0" rtlCol="0" anchor="t"/>
           <a:lstStyle/>
           <a:p>
-            <a:pPr marL="0" indent="0">
+            <a:pPr indent="0" marL="0">
               <a:buNone/>
             </a:pPr>
             <a:r>
@@ -9943,7 +10831,7 @@
             <a:prstDash val="solid"/>
           </a:ln>
           <a:effectLst>
-            <a:outerShdw blurRad="88900" dist="38100" dir="8100000" algn="bl" rotWithShape="0">
+            <a:outerShdw sx="100000" sy="100000" kx="0" ky="0" algn="bl" rotWithShape="0" blurRad="88900" dist="38100" dir="8100000">
               <a:srgbClr val="0E2A3B">
                 <a:alpha val="16000"/>
               </a:srgbClr>
@@ -9952,10 +10840,7 @@
         </p:spPr>
         <p:txBody>
           <a:bodyPr/>
-          <a:lstStyle/>
-          <a:p>
-            <a:endParaRPr/>
-          </a:p>
+          <a:p/>
         </p:txBody>
       </p:sp>
       <p:sp>
@@ -9979,10 +10864,7 @@
         </p:spPr>
         <p:txBody>
           <a:bodyPr/>
-          <a:lstStyle/>
-          <a:p>
-            <a:endParaRPr/>
-          </a:p>
+          <a:p/>
         </p:txBody>
       </p:sp>
       <p:sp>
@@ -10006,7 +10888,7 @@
           <a:bodyPr wrap="square" lIns="0" tIns="0" rIns="0" bIns="0" rtlCol="0" anchor="t"/>
           <a:lstStyle/>
           <a:p>
-            <a:pPr marL="0" indent="0">
+            <a:pPr indent="0" marL="0">
               <a:buNone/>
             </a:pPr>
             <a:r>
@@ -10142,7 +11024,7 @@
             <a:prstDash val="solid"/>
           </a:ln>
           <a:effectLst>
-            <a:outerShdw blurRad="88900" dist="38100" dir="8100000" algn="bl" rotWithShape="0">
+            <a:outerShdw sx="100000" sy="100000" kx="0" ky="0" algn="bl" rotWithShape="0" blurRad="88900" dist="38100" dir="8100000">
               <a:srgbClr val="0E2A3B">
                 <a:alpha val="16000"/>
               </a:srgbClr>
@@ -10151,10 +11033,7 @@
         </p:spPr>
         <p:txBody>
           <a:bodyPr/>
-          <a:lstStyle/>
-          <a:p>
-            <a:endParaRPr/>
-          </a:p>
+          <a:p/>
         </p:txBody>
       </p:sp>
       <p:sp>
@@ -10178,10 +11057,7 @@
         </p:spPr>
         <p:txBody>
           <a:bodyPr/>
-          <a:lstStyle/>
-          <a:p>
-            <a:endParaRPr/>
-          </a:p>
+          <a:p/>
         </p:txBody>
       </p:sp>
       <p:sp>
@@ -10205,7 +11081,7 @@
           <a:bodyPr wrap="square" lIns="0" tIns="0" rIns="0" bIns="0" rtlCol="0" anchor="t"/>
           <a:lstStyle/>
           <a:p>
-            <a:pPr marL="0" indent="0">
+            <a:pPr indent="0" marL="0">
               <a:buNone/>
             </a:pPr>
             <a:r>
@@ -10338,10 +11214,7 @@
         </p:spPr>
         <p:txBody>
           <a:bodyPr/>
-          <a:lstStyle/>
-          <a:p>
-            <a:endParaRPr/>
-          </a:p>
+          <a:p/>
         </p:txBody>
       </p:sp>
       <p:sp>
@@ -10365,10 +11238,7 @@
         </p:spPr>
         <p:txBody>
           <a:bodyPr/>
-          <a:lstStyle/>
-          <a:p>
-            <a:endParaRPr/>
-          </a:p>
+          <a:p/>
         </p:txBody>
       </p:sp>
       <p:sp>
@@ -10392,7 +11262,7 @@
           <a:bodyPr wrap="square" lIns="0" tIns="0" rIns="0" bIns="0" rtlCol="0" anchor="ctr"/>
           <a:lstStyle/>
           <a:p>
-            <a:pPr marL="0" indent="0">
+            <a:pPr indent="0" marL="0">
               <a:buNone/>
             </a:pPr>
             <a:r>
@@ -10431,7 +11301,7 @@
           <a:bodyPr wrap="square" lIns="0" tIns="0" rIns="0" bIns="0" rtlCol="0" anchor="t"/>
           <a:lstStyle/>
           <a:p>
-            <a:pPr marL="0" indent="0">
+            <a:pPr indent="0" marL="0">
               <a:lnSpc>
                 <a:spcPct val="104000"/>
               </a:lnSpc>
@@ -10473,10 +11343,7 @@
         </p:spPr>
         <p:txBody>
           <a:bodyPr/>
-          <a:lstStyle/>
-          <a:p>
-            <a:endParaRPr/>
-          </a:p>
+          <a:p/>
         </p:txBody>
       </p:sp>
       <p:sp>
@@ -10500,7 +11367,7 @@
           <a:bodyPr wrap="square" lIns="0" tIns="0" rIns="0" bIns="0" rtlCol="0" anchor="ctr"/>
           <a:lstStyle/>
           <a:p>
-            <a:pPr marL="0" indent="0">
+            <a:pPr indent="0" marL="0">
               <a:buNone/>
             </a:pPr>
             <a:r>
@@ -10539,7 +11406,7 @@
           <a:bodyPr wrap="square" lIns="0" tIns="0" rIns="0" bIns="0" rtlCol="0" anchor="ctr"/>
           <a:lstStyle/>
           <a:p>
-            <a:pPr marL="0" indent="0" algn="r">
+            <a:pPr algn="r" indent="0" marL="0">
               <a:buNone/>
             </a:pPr>
             <a:r>
@@ -10573,7 +11440,6 @@
         <a:solidFill>
           <a:srgbClr val="F4F0E8"/>
         </a:solidFill>
-        <a:effectLst/>
       </p:bgPr>
     </p:bg>
     <p:spTree>
@@ -10611,10 +11477,7 @@
         </p:spPr>
         <p:txBody>
           <a:bodyPr/>
-          <a:lstStyle/>
-          <a:p>
-            <a:endParaRPr/>
-          </a:p>
+          <a:p/>
         </p:txBody>
       </p:sp>
       <p:sp>
@@ -10638,7 +11501,7 @@
           <a:bodyPr wrap="square" lIns="0" tIns="0" rIns="0" bIns="0" rtlCol="0" anchor="ctr"/>
           <a:lstStyle/>
           <a:p>
-            <a:pPr marL="0" indent="0" algn="ctr">
+            <a:pPr algn="ctr" indent="0" marL="0">
               <a:buNone/>
             </a:pPr>
             <a:r>
@@ -10677,11 +11540,11 @@
           <a:bodyPr wrap="square" lIns="0" tIns="0" rIns="0" bIns="0" rtlCol="0" anchor="ctr"/>
           <a:lstStyle/>
           <a:p>
-            <a:pPr marL="0" indent="0">
+            <a:pPr indent="0" marL="0">
               <a:buNone/>
             </a:pPr>
             <a:r>
-              <a:rPr lang="en-US" sz="1100" b="1" kern="0" spc="200" dirty="0">
+              <a:rPr lang="en-US" sz="1100" b="1" spc="200" kern="0" dirty="0">
                 <a:solidFill>
                   <a:srgbClr val="0E8A82"/>
                 </a:solidFill>
@@ -10716,7 +11579,7 @@
           <a:bodyPr wrap="square" lIns="0" tIns="0" rIns="0" bIns="0" rtlCol="0" anchor="ctr"/>
           <a:lstStyle/>
           <a:p>
-            <a:pPr marL="0" indent="0">
+            <a:pPr indent="0" marL="0">
               <a:buNone/>
             </a:pPr>
             <a:r>
@@ -10758,7 +11621,7 @@
             <a:prstDash val="solid"/>
           </a:ln>
           <a:effectLst>
-            <a:outerShdw blurRad="88900" dist="38100" dir="8100000" algn="bl" rotWithShape="0">
+            <a:outerShdw sx="100000" sy="100000" kx="0" ky="0" algn="bl" rotWithShape="0" blurRad="88900" dist="38100" dir="8100000">
               <a:srgbClr val="0E2A3B">
                 <a:alpha val="16000"/>
               </a:srgbClr>
@@ -10767,10 +11630,7 @@
         </p:spPr>
         <p:txBody>
           <a:bodyPr/>
-          <a:lstStyle/>
-          <a:p>
-            <a:endParaRPr/>
-          </a:p>
+          <a:p/>
         </p:txBody>
       </p:sp>
       <p:sp>
@@ -10794,10 +11654,7 @@
         </p:spPr>
         <p:txBody>
           <a:bodyPr/>
-          <a:lstStyle/>
-          <a:p>
-            <a:endParaRPr/>
-          </a:p>
+          <a:p/>
         </p:txBody>
       </p:sp>
       <p:sp>
@@ -10821,7 +11678,7 @@
           <a:bodyPr wrap="square" lIns="0" tIns="0" rIns="0" bIns="0" rtlCol="0" anchor="ctr"/>
           <a:lstStyle/>
           <a:p>
-            <a:pPr marL="0" indent="0" algn="ctr">
+            <a:pPr algn="ctr" indent="0" marL="0">
               <a:buNone/>
             </a:pPr>
             <a:r>
@@ -10860,7 +11717,7 @@
           <a:bodyPr wrap="square" lIns="0" tIns="0" rIns="0" bIns="0" rtlCol="0" anchor="ctr"/>
           <a:lstStyle/>
           <a:p>
-            <a:pPr marL="0" indent="0">
+            <a:pPr indent="0" marL="0">
               <a:lnSpc>
                 <a:spcPct val="95000"/>
               </a:lnSpc>
@@ -10902,7 +11759,7 @@
           <a:bodyPr wrap="square" lIns="0" tIns="0" rIns="0" bIns="0" rtlCol="0" anchor="t"/>
           <a:lstStyle/>
           <a:p>
-            <a:pPr marL="0" indent="0">
+            <a:pPr indent="0" marL="0">
               <a:lnSpc>
                 <a:spcPct val="102000"/>
               </a:lnSpc>
@@ -10947,7 +11804,7 @@
             <a:prstDash val="solid"/>
           </a:ln>
           <a:effectLst>
-            <a:outerShdw blurRad="88900" dist="38100" dir="8100000" algn="bl" rotWithShape="0">
+            <a:outerShdw sx="100000" sy="100000" kx="0" ky="0" algn="bl" rotWithShape="0" blurRad="88900" dist="38100" dir="8100000">
               <a:srgbClr val="0E2A3B">
                 <a:alpha val="16000"/>
               </a:srgbClr>
@@ -10956,10 +11813,7 @@
         </p:spPr>
         <p:txBody>
           <a:bodyPr/>
-          <a:lstStyle/>
-          <a:p>
-            <a:endParaRPr/>
-          </a:p>
+          <a:p/>
         </p:txBody>
       </p:sp>
       <p:sp>
@@ -10983,10 +11837,7 @@
         </p:spPr>
         <p:txBody>
           <a:bodyPr/>
-          <a:lstStyle/>
-          <a:p>
-            <a:endParaRPr/>
-          </a:p>
+          <a:p/>
         </p:txBody>
       </p:sp>
       <p:sp>
@@ -11010,7 +11861,7 @@
           <a:bodyPr wrap="square" lIns="0" tIns="0" rIns="0" bIns="0" rtlCol="0" anchor="ctr"/>
           <a:lstStyle/>
           <a:p>
-            <a:pPr marL="0" indent="0" algn="ctr">
+            <a:pPr algn="ctr" indent="0" marL="0">
               <a:buNone/>
             </a:pPr>
             <a:r>
@@ -11049,7 +11900,7 @@
           <a:bodyPr wrap="square" lIns="0" tIns="0" rIns="0" bIns="0" rtlCol="0" anchor="ctr"/>
           <a:lstStyle/>
           <a:p>
-            <a:pPr marL="0" indent="0">
+            <a:pPr indent="0" marL="0">
               <a:lnSpc>
                 <a:spcPct val="95000"/>
               </a:lnSpc>
@@ -11091,7 +11942,7 @@
           <a:bodyPr wrap="square" lIns="0" tIns="0" rIns="0" bIns="0" rtlCol="0" anchor="t"/>
           <a:lstStyle/>
           <a:p>
-            <a:pPr marL="0" indent="0">
+            <a:pPr indent="0" marL="0">
               <a:lnSpc>
                 <a:spcPct val="102000"/>
               </a:lnSpc>
@@ -11136,7 +11987,7 @@
             <a:prstDash val="solid"/>
           </a:ln>
           <a:effectLst>
-            <a:outerShdw blurRad="88900" dist="38100" dir="8100000" algn="bl" rotWithShape="0">
+            <a:outerShdw sx="100000" sy="100000" kx="0" ky="0" algn="bl" rotWithShape="0" blurRad="88900" dist="38100" dir="8100000">
               <a:srgbClr val="0E2A3B">
                 <a:alpha val="16000"/>
               </a:srgbClr>
@@ -11145,10 +11996,7 @@
         </p:spPr>
         <p:txBody>
           <a:bodyPr/>
-          <a:lstStyle/>
-          <a:p>
-            <a:endParaRPr/>
-          </a:p>
+          <a:p/>
         </p:txBody>
       </p:sp>
       <p:sp>
@@ -11172,10 +12020,7 @@
         </p:spPr>
         <p:txBody>
           <a:bodyPr/>
-          <a:lstStyle/>
-          <a:p>
-            <a:endParaRPr/>
-          </a:p>
+          <a:p/>
         </p:txBody>
       </p:sp>
       <p:sp>
@@ -11199,7 +12044,7 @@
           <a:bodyPr wrap="square" lIns="0" tIns="0" rIns="0" bIns="0" rtlCol="0" anchor="ctr"/>
           <a:lstStyle/>
           <a:p>
-            <a:pPr marL="0" indent="0" algn="ctr">
+            <a:pPr algn="ctr" indent="0" marL="0">
               <a:buNone/>
             </a:pPr>
             <a:r>
@@ -11238,7 +12083,7 @@
           <a:bodyPr wrap="square" lIns="0" tIns="0" rIns="0" bIns="0" rtlCol="0" anchor="ctr"/>
           <a:lstStyle/>
           <a:p>
-            <a:pPr marL="0" indent="0">
+            <a:pPr indent="0" marL="0">
               <a:lnSpc>
                 <a:spcPct val="95000"/>
               </a:lnSpc>
@@ -11280,7 +12125,7 @@
           <a:bodyPr wrap="square" lIns="0" tIns="0" rIns="0" bIns="0" rtlCol="0" anchor="t"/>
           <a:lstStyle/>
           <a:p>
-            <a:pPr marL="0" indent="0">
+            <a:pPr indent="0" marL="0">
               <a:lnSpc>
                 <a:spcPct val="102000"/>
               </a:lnSpc>
@@ -11325,7 +12170,7 @@
             <a:prstDash val="solid"/>
           </a:ln>
           <a:effectLst>
-            <a:outerShdw blurRad="88900" dist="38100" dir="8100000" algn="bl" rotWithShape="0">
+            <a:outerShdw sx="100000" sy="100000" kx="0" ky="0" algn="bl" rotWithShape="0" blurRad="88900" dist="38100" dir="8100000">
               <a:srgbClr val="0E2A3B">
                 <a:alpha val="16000"/>
               </a:srgbClr>
@@ -11334,10 +12179,7 @@
         </p:spPr>
         <p:txBody>
           <a:bodyPr/>
-          <a:lstStyle/>
-          <a:p>
-            <a:endParaRPr/>
-          </a:p>
+          <a:p/>
         </p:txBody>
       </p:sp>
       <p:sp>
@@ -11361,10 +12203,7 @@
         </p:spPr>
         <p:txBody>
           <a:bodyPr/>
-          <a:lstStyle/>
-          <a:p>
-            <a:endParaRPr/>
-          </a:p>
+          <a:p/>
         </p:txBody>
       </p:sp>
       <p:sp>
@@ -11388,7 +12227,7 @@
           <a:bodyPr wrap="square" lIns="0" tIns="0" rIns="0" bIns="0" rtlCol="0" anchor="ctr"/>
           <a:lstStyle/>
           <a:p>
-            <a:pPr marL="0" indent="0" algn="ctr">
+            <a:pPr algn="ctr" indent="0" marL="0">
               <a:buNone/>
             </a:pPr>
             <a:r>
@@ -11427,7 +12266,7 @@
           <a:bodyPr wrap="square" lIns="0" tIns="0" rIns="0" bIns="0" rtlCol="0" anchor="ctr"/>
           <a:lstStyle/>
           <a:p>
-            <a:pPr marL="0" indent="0">
+            <a:pPr indent="0" marL="0">
               <a:lnSpc>
                 <a:spcPct val="95000"/>
               </a:lnSpc>
@@ -11469,7 +12308,7 @@
           <a:bodyPr wrap="square" lIns="0" tIns="0" rIns="0" bIns="0" rtlCol="0" anchor="t"/>
           <a:lstStyle/>
           <a:p>
-            <a:pPr marL="0" indent="0">
+            <a:pPr indent="0" marL="0">
               <a:lnSpc>
                 <a:spcPct val="102000"/>
               </a:lnSpc>
@@ -11514,7 +12353,7 @@
             <a:prstDash val="solid"/>
           </a:ln>
           <a:effectLst>
-            <a:outerShdw blurRad="88900" dist="38100" dir="8100000" algn="bl" rotWithShape="0">
+            <a:outerShdw sx="100000" sy="100000" kx="0" ky="0" algn="bl" rotWithShape="0" blurRad="88900" dist="38100" dir="8100000">
               <a:srgbClr val="0E2A3B">
                 <a:alpha val="16000"/>
               </a:srgbClr>
@@ -11523,10 +12362,7 @@
         </p:spPr>
         <p:txBody>
           <a:bodyPr/>
-          <a:lstStyle/>
-          <a:p>
-            <a:endParaRPr/>
-          </a:p>
+          <a:p/>
         </p:txBody>
       </p:sp>
       <p:sp>
@@ -11550,10 +12386,7 @@
         </p:spPr>
         <p:txBody>
           <a:bodyPr/>
-          <a:lstStyle/>
-          <a:p>
-            <a:endParaRPr/>
-          </a:p>
+          <a:p/>
         </p:txBody>
       </p:sp>
       <p:sp>
@@ -11577,7 +12410,7 @@
           <a:bodyPr wrap="square" lIns="0" tIns="0" rIns="0" bIns="0" rtlCol="0" anchor="ctr"/>
           <a:lstStyle/>
           <a:p>
-            <a:pPr marL="0" indent="0" algn="ctr">
+            <a:pPr algn="ctr" indent="0" marL="0">
               <a:buNone/>
             </a:pPr>
             <a:r>
@@ -11616,7 +12449,7 @@
           <a:bodyPr wrap="square" lIns="0" tIns="0" rIns="0" bIns="0" rtlCol="0" anchor="ctr"/>
           <a:lstStyle/>
           <a:p>
-            <a:pPr marL="0" indent="0">
+            <a:pPr indent="0" marL="0">
               <a:lnSpc>
                 <a:spcPct val="95000"/>
               </a:lnSpc>
@@ -11658,7 +12491,7 @@
           <a:bodyPr wrap="square" lIns="0" tIns="0" rIns="0" bIns="0" rtlCol="0" anchor="t"/>
           <a:lstStyle/>
           <a:p>
-            <a:pPr marL="0" indent="0">
+            <a:pPr indent="0" marL="0">
               <a:lnSpc>
                 <a:spcPct val="102000"/>
               </a:lnSpc>
@@ -11703,7 +12536,7 @@
             <a:prstDash val="solid"/>
           </a:ln>
           <a:effectLst>
-            <a:outerShdw blurRad="88900" dist="38100" dir="8100000" algn="bl" rotWithShape="0">
+            <a:outerShdw sx="100000" sy="100000" kx="0" ky="0" algn="bl" rotWithShape="0" blurRad="88900" dist="38100" dir="8100000">
               <a:srgbClr val="0E2A3B">
                 <a:alpha val="16000"/>
               </a:srgbClr>
@@ -11712,10 +12545,7 @@
         </p:spPr>
         <p:txBody>
           <a:bodyPr/>
-          <a:lstStyle/>
-          <a:p>
-            <a:endParaRPr/>
-          </a:p>
+          <a:p/>
         </p:txBody>
       </p:sp>
       <p:sp>
@@ -11739,10 +12569,7 @@
         </p:spPr>
         <p:txBody>
           <a:bodyPr/>
-          <a:lstStyle/>
-          <a:p>
-            <a:endParaRPr/>
-          </a:p>
+          <a:p/>
         </p:txBody>
       </p:sp>
       <p:sp>
@@ -11766,7 +12593,7 @@
           <a:bodyPr wrap="square" lIns="0" tIns="0" rIns="0" bIns="0" rtlCol="0" anchor="ctr"/>
           <a:lstStyle/>
           <a:p>
-            <a:pPr marL="0" indent="0" algn="ctr">
+            <a:pPr algn="ctr" indent="0" marL="0">
               <a:buNone/>
             </a:pPr>
             <a:r>
@@ -11805,7 +12632,7 @@
           <a:bodyPr wrap="square" lIns="0" tIns="0" rIns="0" bIns="0" rtlCol="0" anchor="ctr"/>
           <a:lstStyle/>
           <a:p>
-            <a:pPr marL="0" indent="0">
+            <a:pPr indent="0" marL="0">
               <a:lnSpc>
                 <a:spcPct val="95000"/>
               </a:lnSpc>
@@ -11847,7 +12674,7 @@
           <a:bodyPr wrap="square" lIns="0" tIns="0" rIns="0" bIns="0" rtlCol="0" anchor="t"/>
           <a:lstStyle/>
           <a:p>
-            <a:pPr marL="0" indent="0">
+            <a:pPr indent="0" marL="0">
               <a:lnSpc>
                 <a:spcPct val="102000"/>
               </a:lnSpc>
@@ -11889,10 +12716,7 @@
         </p:spPr>
         <p:txBody>
           <a:bodyPr/>
-          <a:lstStyle/>
-          <a:p>
-            <a:endParaRPr/>
-          </a:p>
+          <a:p/>
         </p:txBody>
       </p:sp>
       <p:sp>
@@ -11916,7 +12740,7 @@
           <a:bodyPr wrap="square" lIns="0" tIns="0" rIns="0" bIns="0" rtlCol="0" anchor="ctr"/>
           <a:lstStyle/>
           <a:p>
-            <a:pPr marL="0" indent="0">
+            <a:pPr indent="0" marL="0">
               <a:buNone/>
             </a:pPr>
             <a:r>
@@ -11955,7 +12779,7 @@
           <a:bodyPr wrap="square" lIns="0" tIns="0" rIns="0" bIns="0" rtlCol="0" anchor="ctr"/>
           <a:lstStyle/>
           <a:p>
-            <a:pPr marL="0" indent="0" algn="r">
+            <a:pPr algn="r" indent="0" marL="0">
               <a:buNone/>
             </a:pPr>
             <a:r>
@@ -12274,319 +13098,4 @@
     </a:ext>
   </a:extLst>
 </a:theme>
-</file>
-
-<file path=ppt/theme/theme2.xml><?xml version="1.0" encoding="utf-8"?>
-<a:theme xmlns:a="http://schemas.openxmlformats.org/drawingml/2006/main" name="Office Theme">
-  <a:themeElements>
-    <a:clrScheme name="Office">
-      <a:dk1>
-        <a:sysClr val="windowText" lastClr="000000"/>
-      </a:dk1>
-      <a:lt1>
-        <a:sysClr val="window" lastClr="FFFFFF"/>
-      </a:lt1>
-      <a:dk2>
-        <a:srgbClr val="0E2841"/>
-      </a:dk2>
-      <a:lt2>
-        <a:srgbClr val="E8E8E8"/>
-      </a:lt2>
-      <a:accent1>
-        <a:srgbClr val="156082"/>
-      </a:accent1>
-      <a:accent2>
-        <a:srgbClr val="E97132"/>
-      </a:accent2>
-      <a:accent3>
-        <a:srgbClr val="196B24"/>
-      </a:accent3>
-      <a:accent4>
-        <a:srgbClr val="0F9ED5"/>
-      </a:accent4>
-      <a:accent5>
-        <a:srgbClr val="A02B93"/>
-      </a:accent5>
-      <a:accent6>
-        <a:srgbClr val="4EA72E"/>
-      </a:accent6>
-      <a:hlink>
-        <a:srgbClr val="467886"/>
-      </a:hlink>
-      <a:folHlink>
-        <a:srgbClr val="96607D"/>
-      </a:folHlink>
-    </a:clrScheme>
-    <a:fontScheme name="Office">
-      <a:majorFont>
-        <a:latin typeface="Aptos Display" panose="02110004020202020204"/>
-        <a:ea typeface=""/>
-        <a:cs typeface=""/>
-        <a:font script="Jpan" typeface="游ゴシック Light"/>
-        <a:font script="Hang" typeface="맑은 고딕"/>
-        <a:font script="Hans" typeface="等线 Light"/>
-        <a:font script="Hant" typeface="新細明體"/>
-        <a:font script="Arab" typeface="Times New Roman"/>
-        <a:font script="Hebr" typeface="Times New Roman"/>
-        <a:font script="Thai" typeface="Angsana New"/>
-        <a:font script="Ethi" typeface="Nyala"/>
-        <a:font script="Beng" typeface="Vrinda"/>
-        <a:font script="Gujr" typeface="Shruti"/>
-        <a:font script="Khmr" typeface="MoolBoran"/>
-        <a:font script="Knda" typeface="Tunga"/>
-        <a:font script="Guru" typeface="Raavi"/>
-        <a:font script="Cans" typeface="Euphemia"/>
-        <a:font script="Cher" typeface="Plantagenet Cherokee"/>
-        <a:font script="Yiii" typeface="Microsoft Yi Baiti"/>
-        <a:font script="Tibt" typeface="Microsoft Himalaya"/>
-        <a:font script="Thaa" typeface="MV Boli"/>
-        <a:font script="Deva" typeface="Mangal"/>
-        <a:font script="Telu" typeface="Gautami"/>
-        <a:font script="Taml" typeface="Latha"/>
-        <a:font script="Syrc" typeface="Estrangelo Edessa"/>
-        <a:font script="Orya" typeface="Kalinga"/>
-        <a:font script="Mlym" typeface="Kartika"/>
-        <a:font script="Laoo" typeface="DokChampa"/>
-        <a:font script="Sinh" typeface="Iskoola Pota"/>
-        <a:font script="Mong" typeface="Mongolian Baiti"/>
-        <a:font script="Viet" typeface="Times New Roman"/>
-        <a:font script="Uigh" typeface="Microsoft Uighur"/>
-        <a:font script="Geor" typeface="Sylfaen"/>
-        <a:font script="Armn" typeface="Arial"/>
-        <a:font script="Bugi" typeface="Leelawadee UI"/>
-        <a:font script="Bopo" typeface="Microsoft JhengHei"/>
-        <a:font script="Java" typeface="Javanese Text"/>
-        <a:font script="Lisu" typeface="Segoe UI"/>
-        <a:font script="Mymr" typeface="Myanmar Text"/>
-        <a:font script="Nkoo" typeface="Ebrima"/>
-        <a:font script="Olck" typeface="Nirmala UI"/>
-        <a:font script="Osma" typeface="Ebrima"/>
-        <a:font script="Phag" typeface="Phagspa"/>
-        <a:font script="Syrn" typeface="Estrangelo Edessa"/>
-        <a:font script="Syrj" typeface="Estrangelo Edessa"/>
-        <a:font script="Syre" typeface="Estrangelo Edessa"/>
-        <a:font script="Sora" typeface="Nirmala UI"/>
-        <a:font script="Tale" typeface="Microsoft Tai Le"/>
-        <a:font script="Talu" typeface="Microsoft New Tai Lue"/>
-        <a:font script="Tfng" typeface="Ebrima"/>
-      </a:majorFont>
-      <a:minorFont>
-        <a:latin typeface="Aptos" panose="02110004020202020204"/>
-        <a:ea typeface=""/>
-        <a:cs typeface=""/>
-        <a:font script="Jpan" typeface="游ゴシック"/>
-        <a:font script="Hang" typeface="맑은 고딕"/>
-        <a:font script="Hans" typeface="等线"/>
-        <a:font script="Hant" typeface="新細明體"/>
-        <a:font script="Arab" typeface="Arial"/>
-        <a:font script="Hebr" typeface="Arial"/>
-        <a:font script="Thai" typeface="Cordia New"/>
-        <a:font script="Ethi" typeface="Nyala"/>
-        <a:font script="Beng" typeface="Vrinda"/>
-        <a:font script="Gujr" typeface="Shruti"/>
-        <a:font script="Khmr" typeface="DaunPenh"/>
-        <a:font script="Knda" typeface="Tunga"/>
-        <a:font script="Guru" typeface="Raavi"/>
-        <a:font script="Cans" typeface="Euphemia"/>
-        <a:font script="Cher" typeface="Plantagenet Cherokee"/>
-        <a:font script="Yiii" typeface="Microsoft Yi Baiti"/>
-        <a:font script="Tibt" typeface="Microsoft Himalaya"/>
-        <a:font script="Thaa" typeface="MV Boli"/>
-        <a:font script="Deva" typeface="Mangal"/>
-        <a:font script="Telu" typeface="Gautami"/>
-        <a:font script="Taml" typeface="Latha"/>
-        <a:font script="Syrc" typeface="Estrangelo Edessa"/>
-        <a:font script="Orya" typeface="Kalinga"/>
-        <a:font script="Mlym" typeface="Kartika"/>
-        <a:font script="Laoo" typeface="DokChampa"/>
-        <a:font script="Sinh" typeface="Iskoola Pota"/>
-        <a:font script="Mong" typeface="Mongolian Baiti"/>
-        <a:font script="Viet" typeface="Arial"/>
-        <a:font script="Uigh" typeface="Microsoft Uighur"/>
-        <a:font script="Geor" typeface="Sylfaen"/>
-        <a:font script="Armn" typeface="Arial"/>
-        <a:font script="Bugi" typeface="Leelawadee UI"/>
-        <a:font script="Bopo" typeface="Microsoft JhengHei"/>
-        <a:font script="Java" typeface="Javanese Text"/>
-        <a:font script="Lisu" typeface="Segoe UI"/>
-        <a:font script="Mymr" typeface="Myanmar Text"/>
-        <a:font script="Nkoo" typeface="Ebrima"/>
-        <a:font script="Olck" typeface="Nirmala UI"/>
-        <a:font script="Osma" typeface="Ebrima"/>
-        <a:font script="Phag" typeface="Phagspa"/>
-        <a:font script="Syrn" typeface="Estrangelo Edessa"/>
-        <a:font script="Syrj" typeface="Estrangelo Edessa"/>
-        <a:font script="Syre" typeface="Estrangelo Edessa"/>
-        <a:font script="Sora" typeface="Nirmala UI"/>
-        <a:font script="Tale" typeface="Microsoft Tai Le"/>
-        <a:font script="Talu" typeface="Microsoft New Tai Lue"/>
-        <a:font script="Tfng" typeface="Ebrima"/>
-      </a:minorFont>
-    </a:fontScheme>
-    <a:fmtScheme name="Office">
-      <a:fillStyleLst>
-        <a:solidFill>
-          <a:schemeClr val="phClr"/>
-        </a:solidFill>
-        <a:gradFill rotWithShape="1">
-          <a:gsLst>
-            <a:gs pos="0">
-              <a:schemeClr val="phClr">
-                <a:lumMod val="110000"/>
-                <a:satMod val="105000"/>
-                <a:tint val="67000"/>
-              </a:schemeClr>
-            </a:gs>
-            <a:gs pos="50000">
-              <a:schemeClr val="phClr">
-                <a:lumMod val="105000"/>
-                <a:satMod val="103000"/>
-                <a:tint val="73000"/>
-              </a:schemeClr>
-            </a:gs>
-            <a:gs pos="100000">
-              <a:schemeClr val="phClr">
-                <a:lumMod val="105000"/>
-                <a:satMod val="109000"/>
-                <a:tint val="81000"/>
-              </a:schemeClr>
-            </a:gs>
-          </a:gsLst>
-          <a:lin ang="5400000" scaled="0"/>
-        </a:gradFill>
-        <a:gradFill rotWithShape="1">
-          <a:gsLst>
-            <a:gs pos="0">
-              <a:schemeClr val="phClr">
-                <a:satMod val="103000"/>
-                <a:lumMod val="102000"/>
-                <a:tint val="94000"/>
-              </a:schemeClr>
-            </a:gs>
-            <a:gs pos="50000">
-              <a:schemeClr val="phClr">
-                <a:satMod val="110000"/>
-                <a:lumMod val="100000"/>
-                <a:shade val="100000"/>
-              </a:schemeClr>
-            </a:gs>
-            <a:gs pos="100000">
-              <a:schemeClr val="phClr">
-                <a:lumMod val="99000"/>
-                <a:satMod val="120000"/>
-                <a:shade val="78000"/>
-              </a:schemeClr>
-            </a:gs>
-          </a:gsLst>
-          <a:lin ang="5400000" scaled="0"/>
-        </a:gradFill>
-      </a:fillStyleLst>
-      <a:lnStyleLst>
-        <a:ln w="12700" cap="flat" cmpd="sng" algn="ctr">
-          <a:solidFill>
-            <a:schemeClr val="phClr"/>
-          </a:solidFill>
-          <a:prstDash val="solid"/>
-          <a:miter lim="800000"/>
-        </a:ln>
-        <a:ln w="19050" cap="flat" cmpd="sng" algn="ctr">
-          <a:solidFill>
-            <a:schemeClr val="phClr"/>
-          </a:solidFill>
-          <a:prstDash val="solid"/>
-          <a:miter lim="800000"/>
-        </a:ln>
-        <a:ln w="25400" cap="flat" cmpd="sng" algn="ctr">
-          <a:solidFill>
-            <a:schemeClr val="phClr"/>
-          </a:solidFill>
-          <a:prstDash val="solid"/>
-          <a:miter lim="800000"/>
-        </a:ln>
-      </a:lnStyleLst>
-      <a:effectStyleLst>
-        <a:effectStyle>
-          <a:effectLst/>
-        </a:effectStyle>
-        <a:effectStyle>
-          <a:effectLst/>
-        </a:effectStyle>
-        <a:effectStyle>
-          <a:effectLst>
-            <a:outerShdw blurRad="57150" dist="19050" dir="5400000" algn="ctr" rotWithShape="0">
-              <a:srgbClr val="000000">
-                <a:alpha val="63000"/>
-              </a:srgbClr>
-            </a:outerShdw>
-          </a:effectLst>
-        </a:effectStyle>
-      </a:effectStyleLst>
-      <a:bgFillStyleLst>
-        <a:solidFill>
-          <a:schemeClr val="phClr"/>
-        </a:solidFill>
-        <a:solidFill>
-          <a:schemeClr val="phClr">
-            <a:tint val="95000"/>
-            <a:satMod val="170000"/>
-          </a:schemeClr>
-        </a:solidFill>
-        <a:gradFill rotWithShape="1">
-          <a:gsLst>
-            <a:gs pos="0">
-              <a:schemeClr val="phClr">
-                <a:tint val="93000"/>
-                <a:satMod val="150000"/>
-                <a:shade val="98000"/>
-                <a:lumMod val="102000"/>
-              </a:schemeClr>
-            </a:gs>
-            <a:gs pos="50000">
-              <a:schemeClr val="phClr">
-                <a:tint val="98000"/>
-                <a:satMod val="130000"/>
-                <a:shade val="90000"/>
-                <a:lumMod val="103000"/>
-              </a:schemeClr>
-            </a:gs>
-            <a:gs pos="100000">
-              <a:schemeClr val="phClr">
-                <a:shade val="63000"/>
-                <a:satMod val="120000"/>
-              </a:schemeClr>
-            </a:gs>
-          </a:gsLst>
-          <a:lin ang="5400000" scaled="0"/>
-        </a:gradFill>
-      </a:bgFillStyleLst>
-    </a:fmtScheme>
-  </a:themeElements>
-  <a:objectDefaults>
-    <a:lnDef>
-      <a:spPr/>
-      <a:bodyPr/>
-      <a:lstStyle/>
-      <a:style>
-        <a:lnRef idx="2">
-          <a:schemeClr val="accent1"/>
-        </a:lnRef>
-        <a:fillRef idx="0">
-          <a:schemeClr val="accent1"/>
-        </a:fillRef>
-        <a:effectRef idx="1">
-          <a:schemeClr val="accent1"/>
-        </a:effectRef>
-        <a:fontRef idx="minor">
-          <a:schemeClr val="tx1"/>
-        </a:fontRef>
-      </a:style>
-    </a:lnDef>
-  </a:objectDefaults>
-  <a:extraClrSchemeLst/>
-  <a:extLst>
-    <a:ext uri="{05A4C25C-085E-4340-85A3-A5531E510DB2}">
-      <thm15:themeFamily xmlns:thm15="http://schemas.microsoft.com/office/thememl/2012/main" name="Office Theme" id="{2E142A2C-CD16-42D6-873A-C26D2A0506FA}" vid="{1BDDFF52-6CD6-40A5-AB3C-68EB2F1E4D0A}"/>
-    </a:ext>
-  </a:extLst>
-</a:theme>
 </file>
</xml_diff>

<commit_message>
Update ECOGRID commercial decks, presentation, and prospect data
Co-Authored-By: Claude Opus 4.8 (1M context) <noreply@anthropic.com>
</commit_message>
<xml_diff>
--- a/SmartGrid/Commercial/ECOGRID_RESORT_Investisseurs_FR.pptx
+++ b/SmartGrid/Commercial/ECOGRID_RESORT_Investisseurs_FR.pptx
@@ -3644,7 +3644,7 @@
                 <a:ea typeface="Calibri" pitchFamily="34" charset="-122"/>
                 <a:cs typeface="Calibri" pitchFamily="34" charset="-120"/>
               </a:rPr>
-              <a:t>Solaire sur site : ombrières, toitures, pergolas</a:t>
+              <a:t>Solaire sur site : ombrières, toitures, pergolas. Éolienne (option, si disponible sur site)</a:t>
             </a:r>
             <a:endParaRPr lang="en-US" sz="1050" dirty="0"/>
           </a:p>
@@ -3819,7 +3819,7 @@
                 <a:ea typeface="Calibri" pitchFamily="34" charset="-122"/>
                 <a:cs typeface="Calibri" pitchFamily="34" charset="-120"/>
               </a:rPr>
-              <a:t>Batteries LFP 4–8 MWh : résilience + arbitrage</a:t>
+              <a:t>Batteries LFP 4–8 MWh, V2G-prêtes : résilience, arbitrage &amp; injection réseau local</a:t>
             </a:r>
             <a:endParaRPr lang="en-US" sz="1050" dirty="0"/>
           </a:p>
@@ -4018,7 +4018,7 @@
                 <a:ea typeface="Calibri" pitchFamily="34" charset="-122"/>
                 <a:cs typeface="Calibri" pitchFamily="34" charset="-120"/>
               </a:rPr>
-              <a:t>30–50 bornes VE, recharge intelligente</a:t>
+              <a:t>30–50 bornes VE — recharge intelligente + retour V2G réseau local</a:t>
             </a:r>
             <a:endParaRPr lang="en-US" sz="1050" dirty="0"/>
           </a:p>
@@ -4169,7 +4169,7 @@
                 <a:ea typeface="Calibri" pitchFamily="34" charset="-122"/>
                 <a:cs typeface="Calibri" pitchFamily="34" charset="-120"/>
               </a:rPr>
-              <a:t>App client : EcoScore, réservation VE, récompenses</a:t>
+              <a:t>App vacancier : EcoScore, suivi économies &amp; CO₂ en temps réel, réservation VE, récompenses V2G — bilan personnalisé au départ</a:t>
             </a:r>
             <a:endParaRPr lang="en-US" sz="1050" dirty="0"/>
           </a:p>

</xml_diff>